<commit_message>
feat: generate third presentation L_AROME in White-Blue style with custom fonts and push
</commit_message>
<xml_diff>
--- a/L_AROME_Presentation_TealStyle.pptx
+++ b/L_AROME_Presentation_TealStyle.pptx
@@ -5,24 +5,24 @@
     <p:sldMasterId id="2147483648" r:id="rId1"/>
   </p:sldMasterIdLst>
   <p:sldIdLst>
-    <p:sldId id="256" r:id="rId7"/>
-    <p:sldId id="257" r:id="rId8"/>
-    <p:sldId id="258" r:id="rId9"/>
-    <p:sldId id="259" r:id="rId10"/>
-    <p:sldId id="260" r:id="rId11"/>
-    <p:sldId id="261" r:id="rId12"/>
-    <p:sldId id="262" r:id="rId13"/>
-    <p:sldId id="263" r:id="rId14"/>
-    <p:sldId id="264" r:id="rId15"/>
-    <p:sldId id="265" r:id="rId16"/>
-    <p:sldId id="266" r:id="rId17"/>
-    <p:sldId id="267" r:id="rId18"/>
-    <p:sldId id="268" r:id="rId19"/>
-    <p:sldId id="269" r:id="rId20"/>
-    <p:sldId id="270" r:id="rId21"/>
-    <p:sldId id="271" r:id="rId22"/>
+    <p:sldId id="256" r:id="rId2"/>
+    <p:sldId id="257" r:id="rId3"/>
+    <p:sldId id="258" r:id="rId4"/>
+    <p:sldId id="259" r:id="rId5"/>
+    <p:sldId id="260" r:id="rId6"/>
+    <p:sldId id="261" r:id="rId7"/>
+    <p:sldId id="262" r:id="rId8"/>
+    <p:sldId id="263" r:id="rId9"/>
+    <p:sldId id="264" r:id="rId10"/>
+    <p:sldId id="265" r:id="rId11"/>
+    <p:sldId id="266" r:id="rId12"/>
+    <p:sldId id="267" r:id="rId13"/>
+    <p:sldId id="268" r:id="rId14"/>
+    <p:sldId id="269" r:id="rId15"/>
+    <p:sldId id="270" r:id="rId16"/>
+    <p:sldId id="271" r:id="rId17"/>
   </p:sldIdLst>
-  <p:sldSz cx="12191695" cy="6858000" type="screen4x3"/>
+  <p:sldSz cx="12192000" cy="6858000"/>
   <p:notesSz cx="6858000" cy="9144000"/>
   <p:defaultTextStyle>
     <a:defPPr>
@@ -119,6 +119,22 @@
       </a:defRPr>
     </a:lvl9pPr>
   </p:defaultTextStyle>
+  <p:extLst>
+    <p:ext uri="{EFAFB233-063F-42B5-8137-9DF3F51BA10A}">
+      <p15:sldGuideLst xmlns:p15="http://schemas.microsoft.com/office/powerpoint/2012/main">
+        <p15:guide id="1" orient="horz" pos="2160">
+          <p15:clr>
+            <a:srgbClr val="A4A3A4"/>
+          </p15:clr>
+        </p15:guide>
+        <p15:guide id="2" pos="2880">
+          <p15:clr>
+            <a:srgbClr val="A4A3A4"/>
+          </p15:clr>
+        </p15:guide>
+      </p15:sldGuideLst>
+    </p:ext>
+  </p:extLst>
 </p:presentation>
 </file>
 
@@ -160,10 +176,9 @@
           <a:lstStyle/>
           <a:p>
             <a:r>
-              <a:rPr lang="en-US" smtClean="0"/>
+              <a:rPr lang="en-US"/>
               <a:t>Click to edit Master title style</a:t>
             </a:r>
-            <a:endParaRPr lang="en-US"/>
           </a:p>
         </p:txBody>
       </p:sp>
@@ -279,10 +294,9 @@
           </a:lstStyle>
           <a:p>
             <a:r>
-              <a:rPr lang="en-US" smtClean="0"/>
+              <a:rPr lang="en-US"/>
               <a:t>Click to edit Master subtitle style</a:t>
             </a:r>
-            <a:endParaRPr lang="en-US"/>
           </a:p>
         </p:txBody>
       </p:sp>
@@ -303,7 +317,7 @@
           <a:p>
             <a:fld id="{5BCAD085-E8A6-8845-BD4E-CB4CCA059FC4}" type="datetimeFigureOut">
               <a:rPr lang="en-US" smtClean="0"/>
-              <a:t>1/27/13</a:t>
+              <a:t>7/16/2026</a:t>
             </a:fld>
             <a:endParaRPr lang="en-US"/>
           </a:p>
@@ -397,10 +411,9 @@
           <a:lstStyle/>
           <a:p>
             <a:r>
-              <a:rPr lang="en-US" smtClean="0"/>
+              <a:rPr lang="en-US"/>
               <a:t>Click to edit Master title style</a:t>
             </a:r>
-            <a:endParaRPr lang="en-US"/>
           </a:p>
         </p:txBody>
       </p:sp>
@@ -421,38 +434,37 @@
           <a:p>
             <a:pPr lvl="0"/>
             <a:r>
-              <a:rPr lang="en-US" smtClean="0"/>
+              <a:rPr lang="en-US"/>
               <a:t>Click to edit Master text styles</a:t>
             </a:r>
           </a:p>
           <a:p>
             <a:pPr lvl="1"/>
             <a:r>
-              <a:rPr lang="en-US" smtClean="0"/>
+              <a:rPr lang="en-US"/>
               <a:t>Second level</a:t>
             </a:r>
           </a:p>
           <a:p>
             <a:pPr lvl="2"/>
             <a:r>
-              <a:rPr lang="en-US" smtClean="0"/>
+              <a:rPr lang="en-US"/>
               <a:t>Third level</a:t>
             </a:r>
           </a:p>
           <a:p>
             <a:pPr lvl="3"/>
             <a:r>
-              <a:rPr lang="en-US" smtClean="0"/>
+              <a:rPr lang="en-US"/>
               <a:t>Fourth level</a:t>
             </a:r>
           </a:p>
           <a:p>
             <a:pPr lvl="4"/>
             <a:r>
-              <a:rPr lang="en-US" smtClean="0"/>
+              <a:rPr lang="en-US"/>
               <a:t>Fifth level</a:t>
             </a:r>
-            <a:endParaRPr lang="en-US"/>
           </a:p>
         </p:txBody>
       </p:sp>
@@ -473,7 +485,7 @@
           <a:p>
             <a:fld id="{5BCAD085-E8A6-8845-BD4E-CB4CCA059FC4}" type="datetimeFigureOut">
               <a:rPr lang="en-US" smtClean="0"/>
-              <a:t>1/27/13</a:t>
+              <a:t>7/16/2026</a:t>
             </a:fld>
             <a:endParaRPr lang="en-US"/>
           </a:p>
@@ -572,10 +584,9 @@
           <a:lstStyle/>
           <a:p>
             <a:r>
-              <a:rPr lang="en-US" smtClean="0"/>
+              <a:rPr lang="en-US"/>
               <a:t>Click to edit Master title style</a:t>
             </a:r>
-            <a:endParaRPr lang="en-US"/>
           </a:p>
         </p:txBody>
       </p:sp>
@@ -601,38 +612,37 @@
           <a:p>
             <a:pPr lvl="0"/>
             <a:r>
-              <a:rPr lang="en-US" smtClean="0"/>
+              <a:rPr lang="en-US"/>
               <a:t>Click to edit Master text styles</a:t>
             </a:r>
           </a:p>
           <a:p>
             <a:pPr lvl="1"/>
             <a:r>
-              <a:rPr lang="en-US" smtClean="0"/>
+              <a:rPr lang="en-US"/>
               <a:t>Second level</a:t>
             </a:r>
           </a:p>
           <a:p>
             <a:pPr lvl="2"/>
             <a:r>
-              <a:rPr lang="en-US" smtClean="0"/>
+              <a:rPr lang="en-US"/>
               <a:t>Third level</a:t>
             </a:r>
           </a:p>
           <a:p>
             <a:pPr lvl="3"/>
             <a:r>
-              <a:rPr lang="en-US" smtClean="0"/>
+              <a:rPr lang="en-US"/>
               <a:t>Fourth level</a:t>
             </a:r>
           </a:p>
           <a:p>
             <a:pPr lvl="4"/>
             <a:r>
-              <a:rPr lang="en-US" smtClean="0"/>
+              <a:rPr lang="en-US"/>
               <a:t>Fifth level</a:t>
             </a:r>
-            <a:endParaRPr lang="en-US"/>
           </a:p>
         </p:txBody>
       </p:sp>
@@ -653,7 +663,7 @@
           <a:p>
             <a:fld id="{5BCAD085-E8A6-8845-BD4E-CB4CCA059FC4}" type="datetimeFigureOut">
               <a:rPr lang="en-US" smtClean="0"/>
-              <a:t>1/27/13</a:t>
+              <a:t>7/16/2026</a:t>
             </a:fld>
             <a:endParaRPr lang="en-US"/>
           </a:p>
@@ -747,10 +757,9 @@
           <a:lstStyle/>
           <a:p>
             <a:r>
-              <a:rPr lang="en-US" smtClean="0"/>
+              <a:rPr lang="en-US"/>
               <a:t>Click to edit Master title style</a:t>
             </a:r>
-            <a:endParaRPr lang="en-US"/>
           </a:p>
         </p:txBody>
       </p:sp>
@@ -771,38 +780,37 @@
           <a:p>
             <a:pPr lvl="0"/>
             <a:r>
-              <a:rPr lang="en-US" smtClean="0"/>
+              <a:rPr lang="en-US"/>
               <a:t>Click to edit Master text styles</a:t>
             </a:r>
           </a:p>
           <a:p>
             <a:pPr lvl="1"/>
             <a:r>
-              <a:rPr lang="en-US" smtClean="0"/>
+              <a:rPr lang="en-US"/>
               <a:t>Second level</a:t>
             </a:r>
           </a:p>
           <a:p>
             <a:pPr lvl="2"/>
             <a:r>
-              <a:rPr lang="en-US" smtClean="0"/>
+              <a:rPr lang="en-US"/>
               <a:t>Third level</a:t>
             </a:r>
           </a:p>
           <a:p>
             <a:pPr lvl="3"/>
             <a:r>
-              <a:rPr lang="en-US" smtClean="0"/>
+              <a:rPr lang="en-US"/>
               <a:t>Fourth level</a:t>
             </a:r>
           </a:p>
           <a:p>
             <a:pPr lvl="4"/>
             <a:r>
-              <a:rPr lang="en-US" smtClean="0"/>
+              <a:rPr lang="en-US"/>
               <a:t>Fifth level</a:t>
             </a:r>
-            <a:endParaRPr lang="en-US"/>
           </a:p>
         </p:txBody>
       </p:sp>
@@ -823,7 +831,7 @@
           <a:p>
             <a:fld id="{5BCAD085-E8A6-8845-BD4E-CB4CCA059FC4}" type="datetimeFigureOut">
               <a:rPr lang="en-US" smtClean="0"/>
-              <a:t>1/27/13</a:t>
+              <a:t>7/16/2026</a:t>
             </a:fld>
             <a:endParaRPr lang="en-US"/>
           </a:p>
@@ -926,10 +934,9 @@
           </a:lstStyle>
           <a:p>
             <a:r>
-              <a:rPr lang="en-US" smtClean="0"/>
+              <a:rPr lang="en-US"/>
               <a:t>Click to edit Master title style</a:t>
             </a:r>
-            <a:endParaRPr lang="en-US"/>
           </a:p>
         </p:txBody>
       </p:sp>
@@ -1046,7 +1053,7 @@
           <a:p>
             <a:pPr lvl="0"/>
             <a:r>
-              <a:rPr lang="en-US" smtClean="0"/>
+              <a:rPr lang="en-US"/>
               <a:t>Click to edit Master text styles</a:t>
             </a:r>
           </a:p>
@@ -1069,7 +1076,7 @@
           <a:p>
             <a:fld id="{5BCAD085-E8A6-8845-BD4E-CB4CCA059FC4}" type="datetimeFigureOut">
               <a:rPr lang="en-US" smtClean="0"/>
-              <a:t>1/27/13</a:t>
+              <a:t>7/16/2026</a:t>
             </a:fld>
             <a:endParaRPr lang="en-US"/>
           </a:p>
@@ -1163,10 +1170,9 @@
           <a:lstStyle/>
           <a:p>
             <a:r>
-              <a:rPr lang="en-US" smtClean="0"/>
+              <a:rPr lang="en-US"/>
               <a:t>Click to edit Master title style</a:t>
             </a:r>
-            <a:endParaRPr lang="en-US"/>
           </a:p>
         </p:txBody>
       </p:sp>
@@ -1220,38 +1226,37 @@
           <a:p>
             <a:pPr lvl="0"/>
             <a:r>
-              <a:rPr lang="en-US" smtClean="0"/>
+              <a:rPr lang="en-US"/>
               <a:t>Click to edit Master text styles</a:t>
             </a:r>
           </a:p>
           <a:p>
             <a:pPr lvl="1"/>
             <a:r>
-              <a:rPr lang="en-US" smtClean="0"/>
+              <a:rPr lang="en-US"/>
               <a:t>Second level</a:t>
             </a:r>
           </a:p>
           <a:p>
             <a:pPr lvl="2"/>
             <a:r>
-              <a:rPr lang="en-US" smtClean="0"/>
+              <a:rPr lang="en-US"/>
               <a:t>Third level</a:t>
             </a:r>
           </a:p>
           <a:p>
             <a:pPr lvl="3"/>
             <a:r>
-              <a:rPr lang="en-US" smtClean="0"/>
+              <a:rPr lang="en-US"/>
               <a:t>Fourth level</a:t>
             </a:r>
           </a:p>
           <a:p>
             <a:pPr lvl="4"/>
             <a:r>
-              <a:rPr lang="en-US" smtClean="0"/>
+              <a:rPr lang="en-US"/>
               <a:t>Fifth level</a:t>
             </a:r>
-            <a:endParaRPr lang="en-US"/>
           </a:p>
         </p:txBody>
       </p:sp>
@@ -1305,38 +1310,37 @@
           <a:p>
             <a:pPr lvl="0"/>
             <a:r>
-              <a:rPr lang="en-US" smtClean="0"/>
+              <a:rPr lang="en-US"/>
               <a:t>Click to edit Master text styles</a:t>
             </a:r>
           </a:p>
           <a:p>
             <a:pPr lvl="1"/>
             <a:r>
-              <a:rPr lang="en-US" smtClean="0"/>
+              <a:rPr lang="en-US"/>
               <a:t>Second level</a:t>
             </a:r>
           </a:p>
           <a:p>
             <a:pPr lvl="2"/>
             <a:r>
-              <a:rPr lang="en-US" smtClean="0"/>
+              <a:rPr lang="en-US"/>
               <a:t>Third level</a:t>
             </a:r>
           </a:p>
           <a:p>
             <a:pPr lvl="3"/>
             <a:r>
-              <a:rPr lang="en-US" smtClean="0"/>
+              <a:rPr lang="en-US"/>
               <a:t>Fourth level</a:t>
             </a:r>
           </a:p>
           <a:p>
             <a:pPr lvl="4"/>
             <a:r>
-              <a:rPr lang="en-US" smtClean="0"/>
+              <a:rPr lang="en-US"/>
               <a:t>Fifth level</a:t>
             </a:r>
-            <a:endParaRPr lang="en-US"/>
           </a:p>
         </p:txBody>
       </p:sp>
@@ -1357,7 +1361,7 @@
           <a:p>
             <a:fld id="{5BCAD085-E8A6-8845-BD4E-CB4CCA059FC4}" type="datetimeFigureOut">
               <a:rPr lang="en-US" smtClean="0"/>
-              <a:t>1/27/13</a:t>
+              <a:t>7/16/2026</a:t>
             </a:fld>
             <a:endParaRPr lang="en-US"/>
           </a:p>
@@ -1455,10 +1459,9 @@
           </a:lstStyle>
           <a:p>
             <a:r>
-              <a:rPr lang="en-US" smtClean="0"/>
+              <a:rPr lang="en-US"/>
               <a:t>Click to edit Master title style</a:t>
             </a:r>
-            <a:endParaRPr lang="en-US"/>
           </a:p>
         </p:txBody>
       </p:sp>
@@ -1521,7 +1524,7 @@
           <a:p>
             <a:pPr lvl="0"/>
             <a:r>
-              <a:rPr lang="en-US" smtClean="0"/>
+              <a:rPr lang="en-US"/>
               <a:t>Click to edit Master text styles</a:t>
             </a:r>
           </a:p>
@@ -1577,38 +1580,37 @@
           <a:p>
             <a:pPr lvl="0"/>
             <a:r>
-              <a:rPr lang="en-US" smtClean="0"/>
+              <a:rPr lang="en-US"/>
               <a:t>Click to edit Master text styles</a:t>
             </a:r>
           </a:p>
           <a:p>
             <a:pPr lvl="1"/>
             <a:r>
-              <a:rPr lang="en-US" smtClean="0"/>
+              <a:rPr lang="en-US"/>
               <a:t>Second level</a:t>
             </a:r>
           </a:p>
           <a:p>
             <a:pPr lvl="2"/>
             <a:r>
-              <a:rPr lang="en-US" smtClean="0"/>
+              <a:rPr lang="en-US"/>
               <a:t>Third level</a:t>
             </a:r>
           </a:p>
           <a:p>
             <a:pPr lvl="3"/>
             <a:r>
-              <a:rPr lang="en-US" smtClean="0"/>
+              <a:rPr lang="en-US"/>
               <a:t>Fourth level</a:t>
             </a:r>
           </a:p>
           <a:p>
             <a:pPr lvl="4"/>
             <a:r>
-              <a:rPr lang="en-US" smtClean="0"/>
+              <a:rPr lang="en-US"/>
               <a:t>Fifth level</a:t>
             </a:r>
-            <a:endParaRPr lang="en-US"/>
           </a:p>
         </p:txBody>
       </p:sp>
@@ -1671,7 +1673,7 @@
           <a:p>
             <a:pPr lvl="0"/>
             <a:r>
-              <a:rPr lang="en-US" smtClean="0"/>
+              <a:rPr lang="en-US"/>
               <a:t>Click to edit Master text styles</a:t>
             </a:r>
           </a:p>
@@ -1727,38 +1729,37 @@
           <a:p>
             <a:pPr lvl="0"/>
             <a:r>
-              <a:rPr lang="en-US" smtClean="0"/>
+              <a:rPr lang="en-US"/>
               <a:t>Click to edit Master text styles</a:t>
             </a:r>
           </a:p>
           <a:p>
             <a:pPr lvl="1"/>
             <a:r>
-              <a:rPr lang="en-US" smtClean="0"/>
+              <a:rPr lang="en-US"/>
               <a:t>Second level</a:t>
             </a:r>
           </a:p>
           <a:p>
             <a:pPr lvl="2"/>
             <a:r>
-              <a:rPr lang="en-US" smtClean="0"/>
+              <a:rPr lang="en-US"/>
               <a:t>Third level</a:t>
             </a:r>
           </a:p>
           <a:p>
             <a:pPr lvl="3"/>
             <a:r>
-              <a:rPr lang="en-US" smtClean="0"/>
+              <a:rPr lang="en-US"/>
               <a:t>Fourth level</a:t>
             </a:r>
           </a:p>
           <a:p>
             <a:pPr lvl="4"/>
             <a:r>
-              <a:rPr lang="en-US" smtClean="0"/>
+              <a:rPr lang="en-US"/>
               <a:t>Fifth level</a:t>
             </a:r>
-            <a:endParaRPr lang="en-US"/>
           </a:p>
         </p:txBody>
       </p:sp>
@@ -1779,7 +1780,7 @@
           <a:p>
             <a:fld id="{5BCAD085-E8A6-8845-BD4E-CB4CCA059FC4}" type="datetimeFigureOut">
               <a:rPr lang="en-US" smtClean="0"/>
-              <a:t>1/27/13</a:t>
+              <a:t>7/16/2026</a:t>
             </a:fld>
             <a:endParaRPr lang="en-US"/>
           </a:p>
@@ -1873,10 +1874,9 @@
           <a:lstStyle/>
           <a:p>
             <a:r>
-              <a:rPr lang="en-US" smtClean="0"/>
+              <a:rPr lang="en-US"/>
               <a:t>Click to edit Master title style</a:t>
             </a:r>
-            <a:endParaRPr lang="en-US"/>
           </a:p>
         </p:txBody>
       </p:sp>
@@ -1897,7 +1897,7 @@
           <a:p>
             <a:fld id="{5BCAD085-E8A6-8845-BD4E-CB4CCA059FC4}" type="datetimeFigureOut">
               <a:rPr lang="en-US" smtClean="0"/>
-              <a:t>1/27/13</a:t>
+              <a:t>7/16/2026</a:t>
             </a:fld>
             <a:endParaRPr lang="en-US"/>
           </a:p>
@@ -1992,7 +1992,7 @@
           <a:p>
             <a:fld id="{5BCAD085-E8A6-8845-BD4E-CB4CCA059FC4}" type="datetimeFigureOut">
               <a:rPr lang="en-US" smtClean="0"/>
-              <a:t>1/27/13</a:t>
+              <a:t>7/16/2026</a:t>
             </a:fld>
             <a:endParaRPr lang="en-US"/>
           </a:p>
@@ -2095,10 +2095,9 @@
           </a:lstStyle>
           <a:p>
             <a:r>
-              <a:rPr lang="en-US" smtClean="0"/>
+              <a:rPr lang="en-US"/>
               <a:t>Click to edit Master title style</a:t>
             </a:r>
-            <a:endParaRPr lang="en-US"/>
           </a:p>
         </p:txBody>
       </p:sp>
@@ -2152,38 +2151,37 @@
           <a:p>
             <a:pPr lvl="0"/>
             <a:r>
-              <a:rPr lang="en-US" smtClean="0"/>
+              <a:rPr lang="en-US"/>
               <a:t>Click to edit Master text styles</a:t>
             </a:r>
           </a:p>
           <a:p>
             <a:pPr lvl="1"/>
             <a:r>
-              <a:rPr lang="en-US" smtClean="0"/>
+              <a:rPr lang="en-US"/>
               <a:t>Second level</a:t>
             </a:r>
           </a:p>
           <a:p>
             <a:pPr lvl="2"/>
             <a:r>
-              <a:rPr lang="en-US" smtClean="0"/>
+              <a:rPr lang="en-US"/>
               <a:t>Third level</a:t>
             </a:r>
           </a:p>
           <a:p>
             <a:pPr lvl="3"/>
             <a:r>
-              <a:rPr lang="en-US" smtClean="0"/>
+              <a:rPr lang="en-US"/>
               <a:t>Fourth level</a:t>
             </a:r>
           </a:p>
           <a:p>
             <a:pPr lvl="4"/>
             <a:r>
-              <a:rPr lang="en-US" smtClean="0"/>
+              <a:rPr lang="en-US"/>
               <a:t>Fifth level</a:t>
             </a:r>
-            <a:endParaRPr lang="en-US"/>
           </a:p>
         </p:txBody>
       </p:sp>
@@ -2246,7 +2244,7 @@
           <a:p>
             <a:pPr lvl="0"/>
             <a:r>
-              <a:rPr lang="en-US" smtClean="0"/>
+              <a:rPr lang="en-US"/>
               <a:t>Click to edit Master text styles</a:t>
             </a:r>
           </a:p>
@@ -2269,7 +2267,7 @@
           <a:p>
             <a:fld id="{5BCAD085-E8A6-8845-BD4E-CB4CCA059FC4}" type="datetimeFigureOut">
               <a:rPr lang="en-US" smtClean="0"/>
-              <a:t>1/27/13</a:t>
+              <a:t>7/16/2026</a:t>
             </a:fld>
             <a:endParaRPr lang="en-US"/>
           </a:p>
@@ -2372,10 +2370,9 @@
           </a:lstStyle>
           <a:p>
             <a:r>
-              <a:rPr lang="en-US" smtClean="0"/>
+              <a:rPr lang="en-US"/>
               <a:t>Click to edit Master title style</a:t>
             </a:r>
-            <a:endParaRPr lang="en-US"/>
           </a:p>
         </p:txBody>
       </p:sp>
@@ -2499,7 +2496,7 @@
           <a:p>
             <a:pPr lvl="0"/>
             <a:r>
-              <a:rPr lang="en-US" smtClean="0"/>
+              <a:rPr lang="en-US"/>
               <a:t>Click to edit Master text styles</a:t>
             </a:r>
           </a:p>
@@ -2522,7 +2519,7 @@
           <a:p>
             <a:fld id="{5BCAD085-E8A6-8845-BD4E-CB4CCA059FC4}" type="datetimeFigureOut">
               <a:rPr lang="en-US" smtClean="0"/>
-              <a:t>1/27/13</a:t>
+              <a:t>7/16/2026</a:t>
             </a:fld>
             <a:endParaRPr lang="en-US"/>
           </a:p>
@@ -2631,10 +2628,9 @@
           <a:lstStyle/>
           <a:p>
             <a:r>
-              <a:rPr lang="en-US" smtClean="0"/>
+              <a:rPr lang="en-US"/>
               <a:t>Click to edit Master title style</a:t>
             </a:r>
-            <a:endParaRPr lang="en-US"/>
           </a:p>
         </p:txBody>
       </p:sp>
@@ -2665,38 +2661,37 @@
           <a:p>
             <a:pPr lvl="0"/>
             <a:r>
-              <a:rPr lang="en-US" smtClean="0"/>
+              <a:rPr lang="en-US"/>
               <a:t>Click to edit Master text styles</a:t>
             </a:r>
           </a:p>
           <a:p>
             <a:pPr lvl="1"/>
             <a:r>
-              <a:rPr lang="en-US" smtClean="0"/>
+              <a:rPr lang="en-US"/>
               <a:t>Second level</a:t>
             </a:r>
           </a:p>
           <a:p>
             <a:pPr lvl="2"/>
             <a:r>
-              <a:rPr lang="en-US" smtClean="0"/>
+              <a:rPr lang="en-US"/>
               <a:t>Third level</a:t>
             </a:r>
           </a:p>
           <a:p>
             <a:pPr lvl="3"/>
             <a:r>
-              <a:rPr lang="en-US" smtClean="0"/>
+              <a:rPr lang="en-US"/>
               <a:t>Fourth level</a:t>
             </a:r>
           </a:p>
           <a:p>
             <a:pPr lvl="4"/>
             <a:r>
-              <a:rPr lang="en-US" smtClean="0"/>
+              <a:rPr lang="en-US"/>
               <a:t>Fifth level</a:t>
             </a:r>
-            <a:endParaRPr lang="en-US"/>
           </a:p>
         </p:txBody>
       </p:sp>
@@ -2735,7 +2730,7 @@
           <a:p>
             <a:fld id="{5BCAD085-E8A6-8845-BD4E-CB4CCA059FC4}" type="datetimeFigureOut">
               <a:rPr lang="en-US" smtClean="0"/>
-              <a:t>1/27/13</a:t>
+              <a:t>7/16/2026</a:t>
             </a:fld>
             <a:endParaRPr lang="en-US"/>
           </a:p>
@@ -3094,7 +3089,7 @@
 </file>
 
 <file path=ppt/slides/slide1.xml><?xml version="1.0" encoding="utf-8"?>
-<p:sld xmlns:a="http://schemas.openxmlformats.org/drawingml/2006/main" xmlns:p="http://schemas.openxmlformats.org/presentationml/2006/main" xmlns:r="http://schemas.openxmlformats.org/officeDocument/2006/relationships">
+<p:sld xmlns:a="http://schemas.openxmlformats.org/drawingml/2006/main" xmlns:r="http://schemas.openxmlformats.org/officeDocument/2006/relationships" xmlns:p="http://schemas.openxmlformats.org/presentationml/2006/main">
   <p:cSld>
     <p:bg>
       <p:bgPr>
@@ -3110,7 +3105,14 @@
         <p:cNvGrpSpPr/>
         <p:nvPr/>
       </p:nvGrpSpPr>
-      <p:grpSpPr/>
+      <p:grpSpPr>
+        <a:xfrm>
+          <a:off x="0" y="0"/>
+          <a:ext cx="0" cy="0"/>
+          <a:chOff x="0" y="0"/>
+          <a:chExt cx="0" cy="0"/>
+        </a:xfrm>
+      </p:grpSpPr>
       <p:sp>
         <p:nvSpPr>
           <p:cNvPr id="2" name="Rectangle 1"/>
@@ -3152,6 +3154,7 @@
           <a:lstStyle/>
           <a:p>
             <a:pPr algn="ctr"/>
+            <a:endParaRPr/>
           </a:p>
         </p:txBody>
       </p:sp>
@@ -3172,7 +3175,7 @@
           <a:noFill/>
         </p:spPr>
         <p:txBody>
-          <a:bodyPr wrap="square" anchor="t" lIns="0" tIns="0" rIns="0" bIns="0">
+          <a:bodyPr wrap="square" lIns="0" tIns="0" rIns="0" bIns="0" anchor="t">
             <a:spAutoFit/>
           </a:bodyPr>
           <a:lstStyle/>
@@ -3207,7 +3210,7 @@
           <a:noFill/>
         </p:spPr>
         <p:txBody>
-          <a:bodyPr wrap="square" anchor="t" lIns="0" tIns="0" rIns="0" bIns="0">
+          <a:bodyPr wrap="square" lIns="0" tIns="0" rIns="0" bIns="0" anchor="t">
             <a:spAutoFit/>
           </a:bodyPr>
           <a:lstStyle/>
@@ -3277,7 +3280,7 @@
           <a:noFill/>
         </p:spPr>
         <p:txBody>
-          <a:bodyPr wrap="square" anchor="t" lIns="0" tIns="0" rIns="0" bIns="0">
+          <a:bodyPr wrap="square" lIns="0" tIns="0" rIns="0" bIns="0" anchor="t">
             <a:spAutoFit/>
           </a:bodyPr>
           <a:lstStyle/>
@@ -3312,7 +3315,7 @@
           <a:noFill/>
         </p:spPr>
         <p:txBody>
-          <a:bodyPr wrap="square" anchor="t" lIns="0" tIns="0" rIns="0" bIns="0">
+          <a:bodyPr wrap="square" lIns="0" tIns="0" rIns="0" bIns="0" anchor="t">
             <a:spAutoFit/>
           </a:bodyPr>
           <a:lstStyle/>
@@ -3339,7 +3342,7 @@
 </file>
 
 <file path=ppt/slides/slide10.xml><?xml version="1.0" encoding="utf-8"?>
-<p:sld xmlns:a="http://schemas.openxmlformats.org/drawingml/2006/main" xmlns:p="http://schemas.openxmlformats.org/presentationml/2006/main" xmlns:r="http://schemas.openxmlformats.org/officeDocument/2006/relationships">
+<p:sld xmlns:a="http://schemas.openxmlformats.org/drawingml/2006/main" xmlns:r="http://schemas.openxmlformats.org/officeDocument/2006/relationships" xmlns:p="http://schemas.openxmlformats.org/presentationml/2006/main">
   <p:cSld>
     <p:bg>
       <p:bgPr>
@@ -3355,7 +3358,14 @@
         <p:cNvGrpSpPr/>
         <p:nvPr/>
       </p:nvGrpSpPr>
-      <p:grpSpPr/>
+      <p:grpSpPr>
+        <a:xfrm>
+          <a:off x="0" y="0"/>
+          <a:ext cx="0" cy="0"/>
+          <a:chOff x="0" y="0"/>
+          <a:chExt cx="0" cy="0"/>
+        </a:xfrm>
+      </p:grpSpPr>
       <p:sp>
         <p:nvSpPr>
           <p:cNvPr id="2" name="TextBox 1"/>
@@ -3373,7 +3383,7 @@
           <a:noFill/>
         </p:spPr>
         <p:txBody>
-          <a:bodyPr wrap="square" anchor="t" lIns="0" tIns="0" rIns="0" bIns="0">
+          <a:bodyPr wrap="square" lIns="0" tIns="0" rIns="0" bIns="0" anchor="t">
             <a:spAutoFit/>
           </a:bodyPr>
           <a:lstStyle/>
@@ -3408,7 +3418,7 @@
           <a:noFill/>
         </p:spPr>
         <p:txBody>
-          <a:bodyPr wrap="square" anchor="t" lIns="0" tIns="0" rIns="0" bIns="0">
+          <a:bodyPr wrap="square" lIns="0" tIns="0" rIns="0" bIns="0" anchor="t">
             <a:spAutoFit/>
           </a:bodyPr>
           <a:lstStyle/>
@@ -3478,7 +3488,7 @@
           <a:noFill/>
         </p:spPr>
         <p:txBody>
-          <a:bodyPr wrap="square" anchor="t" lIns="0" tIns="0" rIns="0" bIns="0">
+          <a:bodyPr wrap="square" lIns="0" tIns="0" rIns="0" bIns="0" anchor="t">
             <a:spAutoFit/>
           </a:bodyPr>
           <a:lstStyle/>
@@ -3505,7 +3515,7 @@
 </file>
 
 <file path=ppt/slides/slide11.xml><?xml version="1.0" encoding="utf-8"?>
-<p:sld xmlns:a="http://schemas.openxmlformats.org/drawingml/2006/main" xmlns:p="http://schemas.openxmlformats.org/presentationml/2006/main" xmlns:r="http://schemas.openxmlformats.org/officeDocument/2006/relationships">
+<p:sld xmlns:a="http://schemas.openxmlformats.org/drawingml/2006/main" xmlns:r="http://schemas.openxmlformats.org/officeDocument/2006/relationships" xmlns:p="http://schemas.openxmlformats.org/presentationml/2006/main">
   <p:cSld>
     <p:bg>
       <p:bgPr>
@@ -3521,7 +3531,14 @@
         <p:cNvGrpSpPr/>
         <p:nvPr/>
       </p:nvGrpSpPr>
-      <p:grpSpPr/>
+      <p:grpSpPr>
+        <a:xfrm>
+          <a:off x="0" y="0"/>
+          <a:ext cx="0" cy="0"/>
+          <a:chOff x="0" y="0"/>
+          <a:chExt cx="0" cy="0"/>
+        </a:xfrm>
+      </p:grpSpPr>
       <p:sp>
         <p:nvSpPr>
           <p:cNvPr id="2" name="TextBox 1"/>
@@ -3539,7 +3556,7 @@
           <a:noFill/>
         </p:spPr>
         <p:txBody>
-          <a:bodyPr wrap="square" anchor="t" lIns="0" tIns="0" rIns="0" bIns="0">
+          <a:bodyPr wrap="square" lIns="0" tIns="0" rIns="0" bIns="0" anchor="t">
             <a:spAutoFit/>
           </a:bodyPr>
           <a:lstStyle/>
@@ -3574,7 +3591,7 @@
           <a:noFill/>
         </p:spPr>
         <p:txBody>
-          <a:bodyPr wrap="square" anchor="t" lIns="0" tIns="0" rIns="0" bIns="0">
+          <a:bodyPr wrap="square" lIns="0" tIns="0" rIns="0" bIns="0" anchor="t">
             <a:spAutoFit/>
           </a:bodyPr>
           <a:lstStyle/>
@@ -3644,7 +3661,7 @@
           <a:noFill/>
         </p:spPr>
         <p:txBody>
-          <a:bodyPr wrap="square" anchor="t" lIns="0" tIns="0" rIns="0" bIns="0">
+          <a:bodyPr wrap="square" lIns="0" tIns="0" rIns="0" bIns="0" anchor="t">
             <a:spAutoFit/>
           </a:bodyPr>
           <a:lstStyle/>
@@ -3749,17 +3766,6 @@
           </a:p>
           <a:p>
             <a:br/>
-            <a:pPr>
-              <a:spcAft>
-                <a:spcPts val="800"/>
-              </a:spcAft>
-              <a:defRPr sz="1500" b="1">
-                <a:solidFill>
-                  <a:srgbClr val="134E4A"/>
-                </a:solidFill>
-                <a:latin typeface="Malgun Gothic"/>
-              </a:defRPr>
-            </a:pPr>
             <a:r>
               <a:t>• AI 추론 API (`/api/chat`) 연계</a:t>
             </a:r>
@@ -3807,7 +3813,7 @@
 </file>
 
 <file path=ppt/slides/slide12.xml><?xml version="1.0" encoding="utf-8"?>
-<p:sld xmlns:a="http://schemas.openxmlformats.org/drawingml/2006/main" xmlns:p="http://schemas.openxmlformats.org/presentationml/2006/main" xmlns:r="http://schemas.openxmlformats.org/officeDocument/2006/relationships">
+<p:sld xmlns:a="http://schemas.openxmlformats.org/drawingml/2006/main" xmlns:r="http://schemas.openxmlformats.org/officeDocument/2006/relationships" xmlns:p="http://schemas.openxmlformats.org/presentationml/2006/main">
   <p:cSld>
     <p:bg>
       <p:bgPr>
@@ -3823,7 +3829,14 @@
         <p:cNvGrpSpPr/>
         <p:nvPr/>
       </p:nvGrpSpPr>
-      <p:grpSpPr/>
+      <p:grpSpPr>
+        <a:xfrm>
+          <a:off x="0" y="0"/>
+          <a:ext cx="0" cy="0"/>
+          <a:chOff x="0" y="0"/>
+          <a:chExt cx="0" cy="0"/>
+        </a:xfrm>
+      </p:grpSpPr>
       <p:sp>
         <p:nvSpPr>
           <p:cNvPr id="2" name="TextBox 1"/>
@@ -3841,7 +3854,7 @@
           <a:noFill/>
         </p:spPr>
         <p:txBody>
-          <a:bodyPr wrap="square" anchor="t" lIns="0" tIns="0" rIns="0" bIns="0">
+          <a:bodyPr wrap="square" lIns="0" tIns="0" rIns="0" bIns="0" anchor="t">
             <a:spAutoFit/>
           </a:bodyPr>
           <a:lstStyle/>
@@ -3876,7 +3889,7 @@
           <a:noFill/>
         </p:spPr>
         <p:txBody>
-          <a:bodyPr wrap="square" anchor="t" lIns="0" tIns="0" rIns="0" bIns="0">
+          <a:bodyPr wrap="square" lIns="0" tIns="0" rIns="0" bIns="0" anchor="t">
             <a:spAutoFit/>
           </a:bodyPr>
           <a:lstStyle/>
@@ -3946,7 +3959,7 @@
           <a:noFill/>
         </p:spPr>
         <p:txBody>
-          <a:bodyPr wrap="square" anchor="t" lIns="0" tIns="0" rIns="0" bIns="0">
+          <a:bodyPr wrap="square" lIns="0" tIns="0" rIns="0" bIns="0" anchor="t">
             <a:spAutoFit/>
           </a:bodyPr>
           <a:lstStyle/>
@@ -4019,17 +4032,6 @@
           </a:p>
           <a:p>
             <a:br/>
-            <a:pPr>
-              <a:spcAft>
-                <a:spcPts val="800"/>
-              </a:spcAft>
-              <a:defRPr sz="1500" b="1">
-                <a:solidFill>
-                  <a:srgbClr val="134E4A"/>
-                </a:solidFill>
-                <a:latin typeface="Malgun Gothic"/>
-              </a:defRPr>
-            </a:pPr>
             <a:r>
               <a:t>• 외래키 관계 및 연쇄 삭제 (Cascade Delete)</a:t>
             </a:r>
@@ -4101,7 +4103,7 @@
 </file>
 
 <file path=ppt/slides/slide13.xml><?xml version="1.0" encoding="utf-8"?>
-<p:sld xmlns:a="http://schemas.openxmlformats.org/drawingml/2006/main" xmlns:p="http://schemas.openxmlformats.org/presentationml/2006/main" xmlns:r="http://schemas.openxmlformats.org/officeDocument/2006/relationships">
+<p:sld xmlns:a="http://schemas.openxmlformats.org/drawingml/2006/main" xmlns:r="http://schemas.openxmlformats.org/officeDocument/2006/relationships" xmlns:p="http://schemas.openxmlformats.org/presentationml/2006/main">
   <p:cSld>
     <p:bg>
       <p:bgPr>
@@ -4117,7 +4119,14 @@
         <p:cNvGrpSpPr/>
         <p:nvPr/>
       </p:nvGrpSpPr>
-      <p:grpSpPr/>
+      <p:grpSpPr>
+        <a:xfrm>
+          <a:off x="0" y="0"/>
+          <a:ext cx="0" cy="0"/>
+          <a:chOff x="0" y="0"/>
+          <a:chExt cx="0" cy="0"/>
+        </a:xfrm>
+      </p:grpSpPr>
       <p:sp>
         <p:nvSpPr>
           <p:cNvPr id="2" name="TextBox 1"/>
@@ -4135,7 +4144,7 @@
           <a:noFill/>
         </p:spPr>
         <p:txBody>
-          <a:bodyPr wrap="square" anchor="t" lIns="0" tIns="0" rIns="0" bIns="0">
+          <a:bodyPr wrap="square" lIns="0" tIns="0" rIns="0" bIns="0" anchor="t">
             <a:spAutoFit/>
           </a:bodyPr>
           <a:lstStyle/>
@@ -4170,7 +4179,7 @@
           <a:noFill/>
         </p:spPr>
         <p:txBody>
-          <a:bodyPr wrap="square" anchor="t" lIns="0" tIns="0" rIns="0" bIns="0">
+          <a:bodyPr wrap="square" lIns="0" tIns="0" rIns="0" bIns="0" anchor="t">
             <a:spAutoFit/>
           </a:bodyPr>
           <a:lstStyle/>
@@ -4240,7 +4249,7 @@
           <a:noFill/>
         </p:spPr>
         <p:txBody>
-          <a:bodyPr wrap="square" anchor="t" lIns="0" tIns="0" rIns="0" bIns="0">
+          <a:bodyPr wrap="square" lIns="0" tIns="0" rIns="0" bIns="0" anchor="t">
             <a:spAutoFit/>
           </a:bodyPr>
           <a:lstStyle/>
@@ -4267,7 +4276,7 @@
 </file>
 
 <file path=ppt/slides/slide14.xml><?xml version="1.0" encoding="utf-8"?>
-<p:sld xmlns:a="http://schemas.openxmlformats.org/drawingml/2006/main" xmlns:p="http://schemas.openxmlformats.org/presentationml/2006/main" xmlns:r="http://schemas.openxmlformats.org/officeDocument/2006/relationships">
+<p:sld xmlns:a="http://schemas.openxmlformats.org/drawingml/2006/main" xmlns:r="http://schemas.openxmlformats.org/officeDocument/2006/relationships" xmlns:p="http://schemas.openxmlformats.org/presentationml/2006/main">
   <p:cSld>
     <p:bg>
       <p:bgPr>
@@ -4283,7 +4292,14 @@
         <p:cNvGrpSpPr/>
         <p:nvPr/>
       </p:nvGrpSpPr>
-      <p:grpSpPr/>
+      <p:grpSpPr>
+        <a:xfrm>
+          <a:off x="0" y="0"/>
+          <a:ext cx="0" cy="0"/>
+          <a:chOff x="0" y="0"/>
+          <a:chExt cx="0" cy="0"/>
+        </a:xfrm>
+      </p:grpSpPr>
       <p:sp>
         <p:nvSpPr>
           <p:cNvPr id="2" name="TextBox 1"/>
@@ -4301,7 +4317,7 @@
           <a:noFill/>
         </p:spPr>
         <p:txBody>
-          <a:bodyPr wrap="square" anchor="t" lIns="0" tIns="0" rIns="0" bIns="0">
+          <a:bodyPr wrap="square" lIns="0" tIns="0" rIns="0" bIns="0" anchor="t">
             <a:spAutoFit/>
           </a:bodyPr>
           <a:lstStyle/>
@@ -4336,7 +4352,7 @@
           <a:noFill/>
         </p:spPr>
         <p:txBody>
-          <a:bodyPr wrap="square" anchor="t" lIns="0" tIns="0" rIns="0" bIns="0">
+          <a:bodyPr wrap="square" lIns="0" tIns="0" rIns="0" bIns="0" anchor="t">
             <a:spAutoFit/>
           </a:bodyPr>
           <a:lstStyle/>
@@ -4406,7 +4422,7 @@
           <a:noFill/>
         </p:spPr>
         <p:txBody>
-          <a:bodyPr wrap="square" anchor="t" lIns="0" tIns="0" rIns="0" bIns="0">
+          <a:bodyPr wrap="square" lIns="0" tIns="0" rIns="0" bIns="0" anchor="t">
             <a:spAutoFit/>
           </a:bodyPr>
           <a:lstStyle/>
@@ -4479,17 +4495,6 @@
           </a:p>
           <a:p>
             <a:br/>
-            <a:pPr>
-              <a:spcAft>
-                <a:spcPts val="800"/>
-              </a:spcAft>
-              <a:defRPr sz="1500" b="1">
-                <a:solidFill>
-                  <a:srgbClr val="134E4A"/>
-                </a:solidFill>
-                <a:latin typeface="Malgun Gothic"/>
-              </a:defRPr>
-            </a:pPr>
             <a:r>
               <a:t>• SeatMap 좌석 비활성화 동적 락</a:t>
             </a:r>
@@ -4512,17 +4517,6 @@
           </a:p>
           <a:p>
             <a:br/>
-            <a:pPr>
-              <a:spcAft>
-                <a:spcPts val="800"/>
-              </a:spcAft>
-              <a:defRPr sz="1500" b="1">
-                <a:solidFill>
-                  <a:srgbClr val="134E4A"/>
-                </a:solidFill>
-                <a:latin typeface="Malgun Gothic"/>
-              </a:defRPr>
-            </a:pPr>
             <a:r>
               <a:t>• DB 트랜잭션 충돌 차단</a:t>
             </a:r>
@@ -4554,7 +4548,7 @@
 </file>
 
 <file path=ppt/slides/slide15.xml><?xml version="1.0" encoding="utf-8"?>
-<p:sld xmlns:a="http://schemas.openxmlformats.org/drawingml/2006/main" xmlns:p="http://schemas.openxmlformats.org/presentationml/2006/main" xmlns:r="http://schemas.openxmlformats.org/officeDocument/2006/relationships">
+<p:sld xmlns:a="http://schemas.openxmlformats.org/drawingml/2006/main" xmlns:r="http://schemas.openxmlformats.org/officeDocument/2006/relationships" xmlns:p="http://schemas.openxmlformats.org/presentationml/2006/main">
   <p:cSld>
     <p:bg>
       <p:bgPr>
@@ -4570,7 +4564,14 @@
         <p:cNvGrpSpPr/>
         <p:nvPr/>
       </p:nvGrpSpPr>
-      <p:grpSpPr/>
+      <p:grpSpPr>
+        <a:xfrm>
+          <a:off x="0" y="0"/>
+          <a:ext cx="0" cy="0"/>
+          <a:chOff x="0" y="0"/>
+          <a:chExt cx="0" cy="0"/>
+        </a:xfrm>
+      </p:grpSpPr>
       <p:sp>
         <p:nvSpPr>
           <p:cNvPr id="2" name="TextBox 1"/>
@@ -4588,7 +4589,7 @@
           <a:noFill/>
         </p:spPr>
         <p:txBody>
-          <a:bodyPr wrap="square" anchor="t" lIns="0" tIns="0" rIns="0" bIns="0">
+          <a:bodyPr wrap="square" lIns="0" tIns="0" rIns="0" bIns="0" anchor="t">
             <a:spAutoFit/>
           </a:bodyPr>
           <a:lstStyle/>
@@ -4623,7 +4624,7 @@
           <a:noFill/>
         </p:spPr>
         <p:txBody>
-          <a:bodyPr wrap="square" anchor="t" lIns="0" tIns="0" rIns="0" bIns="0">
+          <a:bodyPr wrap="square" lIns="0" tIns="0" rIns="0" bIns="0" anchor="t">
             <a:spAutoFit/>
           </a:bodyPr>
           <a:lstStyle/>
@@ -4693,7 +4694,7 @@
           <a:noFill/>
         </p:spPr>
         <p:txBody>
-          <a:bodyPr wrap="square" anchor="t" lIns="0" tIns="0" rIns="0" bIns="0">
+          <a:bodyPr wrap="square" lIns="0" tIns="0" rIns="0" bIns="0" anchor="t">
             <a:spAutoFit/>
           </a:bodyPr>
           <a:lstStyle/>
@@ -4766,17 +4767,6 @@
           </a:p>
           <a:p>
             <a:br/>
-            <a:pPr>
-              <a:spcAft>
-                <a:spcPts val="800"/>
-              </a:spcAft>
-              <a:defRPr sz="1400" b="1">
-                <a:solidFill>
-                  <a:srgbClr val="134E4A"/>
-                </a:solidFill>
-                <a:latin typeface="Malgun Gothic"/>
-              </a:defRPr>
-            </a:pPr>
             <a:r>
               <a:t>• 어드민 예약 처리 연동 실시간 좌석 복원</a:t>
             </a:r>
@@ -4824,7 +4814,7 @@
 </file>
 
 <file path=ppt/slides/slide16.xml><?xml version="1.0" encoding="utf-8"?>
-<p:sld xmlns:a="http://schemas.openxmlformats.org/drawingml/2006/main" xmlns:p="http://schemas.openxmlformats.org/presentationml/2006/main" xmlns:r="http://schemas.openxmlformats.org/officeDocument/2006/relationships">
+<p:sld xmlns:a="http://schemas.openxmlformats.org/drawingml/2006/main" xmlns:r="http://schemas.openxmlformats.org/officeDocument/2006/relationships" xmlns:p="http://schemas.openxmlformats.org/presentationml/2006/main">
   <p:cSld>
     <p:bg>
       <p:bgPr>
@@ -4840,7 +4830,14 @@
         <p:cNvGrpSpPr/>
         <p:nvPr/>
       </p:nvGrpSpPr>
-      <p:grpSpPr/>
+      <p:grpSpPr>
+        <a:xfrm>
+          <a:off x="0" y="0"/>
+          <a:ext cx="0" cy="0"/>
+          <a:chOff x="0" y="0"/>
+          <a:chExt cx="0" cy="0"/>
+        </a:xfrm>
+      </p:grpSpPr>
       <p:sp>
         <p:nvSpPr>
           <p:cNvPr id="2" name="TextBox 1"/>
@@ -4858,7 +4855,7 @@
           <a:noFill/>
         </p:spPr>
         <p:txBody>
-          <a:bodyPr wrap="square" anchor="t" lIns="0" tIns="0" rIns="0" bIns="0">
+          <a:bodyPr wrap="square" lIns="0" tIns="0" rIns="0" bIns="0" anchor="t">
             <a:spAutoFit/>
           </a:bodyPr>
           <a:lstStyle/>
@@ -4893,7 +4890,7 @@
           <a:noFill/>
         </p:spPr>
         <p:txBody>
-          <a:bodyPr wrap="square" anchor="t" lIns="0" tIns="0" rIns="0" bIns="0">
+          <a:bodyPr wrap="square" lIns="0" tIns="0" rIns="0" bIns="0" anchor="t">
             <a:spAutoFit/>
           </a:bodyPr>
           <a:lstStyle/>
@@ -4928,7 +4925,7 @@
           <a:noFill/>
         </p:spPr>
         <p:txBody>
-          <a:bodyPr wrap="square" anchor="t" lIns="0" tIns="0" rIns="0" bIns="0">
+          <a:bodyPr wrap="square" lIns="0" tIns="0" rIns="0" bIns="0" anchor="t">
             <a:spAutoFit/>
           </a:bodyPr>
           <a:lstStyle/>
@@ -4955,7 +4952,7 @@
 </file>
 
 <file path=ppt/slides/slide2.xml><?xml version="1.0" encoding="utf-8"?>
-<p:sld xmlns:a="http://schemas.openxmlformats.org/drawingml/2006/main" xmlns:p="http://schemas.openxmlformats.org/presentationml/2006/main" xmlns:r="http://schemas.openxmlformats.org/officeDocument/2006/relationships">
+<p:sld xmlns:a="http://schemas.openxmlformats.org/drawingml/2006/main" xmlns:r="http://schemas.openxmlformats.org/officeDocument/2006/relationships" xmlns:p="http://schemas.openxmlformats.org/presentationml/2006/main">
   <p:cSld>
     <p:bg>
       <p:bgPr>
@@ -4971,7 +4968,14 @@
         <p:cNvGrpSpPr/>
         <p:nvPr/>
       </p:nvGrpSpPr>
-      <p:grpSpPr/>
+      <p:grpSpPr>
+        <a:xfrm>
+          <a:off x="0" y="0"/>
+          <a:ext cx="0" cy="0"/>
+          <a:chOff x="0" y="0"/>
+          <a:chExt cx="0" cy="0"/>
+        </a:xfrm>
+      </p:grpSpPr>
       <p:sp>
         <p:nvSpPr>
           <p:cNvPr id="2" name="TextBox 1"/>
@@ -4989,7 +4993,7 @@
           <a:noFill/>
         </p:spPr>
         <p:txBody>
-          <a:bodyPr wrap="square" anchor="t" lIns="0" tIns="0" rIns="0" bIns="0">
+          <a:bodyPr wrap="square" lIns="0" tIns="0" rIns="0" bIns="0" anchor="t">
             <a:spAutoFit/>
           </a:bodyPr>
           <a:lstStyle/>
@@ -5024,7 +5028,7 @@
           <a:noFill/>
         </p:spPr>
         <p:txBody>
-          <a:bodyPr wrap="square" anchor="t" lIns="0" tIns="0" rIns="0" bIns="0">
+          <a:bodyPr wrap="square" lIns="0" tIns="0" rIns="0" bIns="0" anchor="t">
             <a:spAutoFit/>
           </a:bodyPr>
           <a:lstStyle/>
@@ -5094,7 +5098,7 @@
           <a:noFill/>
         </p:spPr>
         <p:txBody>
-          <a:bodyPr wrap="square" anchor="t" lIns="0" tIns="0" rIns="0" bIns="0">
+          <a:bodyPr wrap="square" lIns="0" tIns="0" rIns="0" bIns="0" anchor="t">
             <a:spAutoFit/>
           </a:bodyPr>
           <a:lstStyle/>
@@ -5129,7 +5133,7 @@
           <a:noFill/>
         </p:spPr>
         <p:txBody>
-          <a:bodyPr wrap="square" anchor="t" lIns="0" tIns="0" rIns="0" bIns="0">
+          <a:bodyPr wrap="square" lIns="0" tIns="0" rIns="0" bIns="0" anchor="t">
             <a:spAutoFit/>
           </a:bodyPr>
           <a:lstStyle/>
@@ -5164,7 +5168,7 @@
           <a:noFill/>
         </p:spPr>
         <p:txBody>
-          <a:bodyPr wrap="square" anchor="t" lIns="0" tIns="0" rIns="0" bIns="0">
+          <a:bodyPr wrap="square" lIns="0" tIns="0" rIns="0" bIns="0" anchor="t">
             <a:spAutoFit/>
           </a:bodyPr>
           <a:lstStyle/>
@@ -5234,7 +5238,7 @@
           <a:noFill/>
         </p:spPr>
         <p:txBody>
-          <a:bodyPr wrap="square" anchor="t" lIns="0" tIns="0" rIns="0" bIns="0">
+          <a:bodyPr wrap="square" lIns="0" tIns="0" rIns="0" bIns="0" anchor="t">
             <a:spAutoFit/>
           </a:bodyPr>
           <a:lstStyle/>
@@ -5269,7 +5273,7 @@
           <a:noFill/>
         </p:spPr>
         <p:txBody>
-          <a:bodyPr wrap="square" anchor="t" lIns="0" tIns="0" rIns="0" bIns="0">
+          <a:bodyPr wrap="square" lIns="0" tIns="0" rIns="0" bIns="0" anchor="t">
             <a:spAutoFit/>
           </a:bodyPr>
           <a:lstStyle/>
@@ -5339,7 +5343,7 @@
           <a:noFill/>
         </p:spPr>
         <p:txBody>
-          <a:bodyPr wrap="square" anchor="t" lIns="0" tIns="0" rIns="0" bIns="0">
+          <a:bodyPr wrap="square" lIns="0" tIns="0" rIns="0" bIns="0" anchor="t">
             <a:spAutoFit/>
           </a:bodyPr>
           <a:lstStyle/>
@@ -5374,7 +5378,7 @@
           <a:noFill/>
         </p:spPr>
         <p:txBody>
-          <a:bodyPr wrap="square" anchor="t" lIns="0" tIns="0" rIns="0" bIns="0">
+          <a:bodyPr wrap="square" lIns="0" tIns="0" rIns="0" bIns="0" anchor="t">
             <a:spAutoFit/>
           </a:bodyPr>
           <a:lstStyle/>
@@ -5444,7 +5448,7 @@
           <a:noFill/>
         </p:spPr>
         <p:txBody>
-          <a:bodyPr wrap="square" anchor="t" lIns="0" tIns="0" rIns="0" bIns="0">
+          <a:bodyPr wrap="square" lIns="0" tIns="0" rIns="0" bIns="0" anchor="t">
             <a:spAutoFit/>
           </a:bodyPr>
           <a:lstStyle/>
@@ -5479,7 +5483,7 @@
           <a:noFill/>
         </p:spPr>
         <p:txBody>
-          <a:bodyPr wrap="square" anchor="t" lIns="0" tIns="0" rIns="0" bIns="0">
+          <a:bodyPr wrap="square" lIns="0" tIns="0" rIns="0" bIns="0" anchor="t">
             <a:spAutoFit/>
           </a:bodyPr>
           <a:lstStyle/>
@@ -5549,7 +5553,7 @@
           <a:noFill/>
         </p:spPr>
         <p:txBody>
-          <a:bodyPr wrap="square" anchor="t" lIns="0" tIns="0" rIns="0" bIns="0">
+          <a:bodyPr wrap="square" lIns="0" tIns="0" rIns="0" bIns="0" anchor="t">
             <a:spAutoFit/>
           </a:bodyPr>
           <a:lstStyle/>
@@ -5584,7 +5588,7 @@
           <a:noFill/>
         </p:spPr>
         <p:txBody>
-          <a:bodyPr wrap="square" anchor="t" lIns="0" tIns="0" rIns="0" bIns="0">
+          <a:bodyPr wrap="square" lIns="0" tIns="0" rIns="0" bIns="0" anchor="t">
             <a:spAutoFit/>
           </a:bodyPr>
           <a:lstStyle/>
@@ -5646,7 +5650,7 @@
 </file>
 
 <file path=ppt/slides/slide3.xml><?xml version="1.0" encoding="utf-8"?>
-<p:sld xmlns:a="http://schemas.openxmlformats.org/drawingml/2006/main" xmlns:p="http://schemas.openxmlformats.org/presentationml/2006/main" xmlns:r="http://schemas.openxmlformats.org/officeDocument/2006/relationships">
+<p:sld xmlns:a="http://schemas.openxmlformats.org/drawingml/2006/main" xmlns:r="http://schemas.openxmlformats.org/officeDocument/2006/relationships" xmlns:p="http://schemas.openxmlformats.org/presentationml/2006/main">
   <p:cSld>
     <p:bg>
       <p:bgPr>
@@ -5662,7 +5666,14 @@
         <p:cNvGrpSpPr/>
         <p:nvPr/>
       </p:nvGrpSpPr>
-      <p:grpSpPr/>
+      <p:grpSpPr>
+        <a:xfrm>
+          <a:off x="0" y="0"/>
+          <a:ext cx="0" cy="0"/>
+          <a:chOff x="0" y="0"/>
+          <a:chExt cx="0" cy="0"/>
+        </a:xfrm>
+      </p:grpSpPr>
       <p:sp>
         <p:nvSpPr>
           <p:cNvPr id="2" name="TextBox 1"/>
@@ -5680,7 +5691,7 @@
           <a:noFill/>
         </p:spPr>
         <p:txBody>
-          <a:bodyPr wrap="square" anchor="t" lIns="0" tIns="0" rIns="0" bIns="0">
+          <a:bodyPr wrap="square" lIns="0" tIns="0" rIns="0" bIns="0" anchor="t">
             <a:spAutoFit/>
           </a:bodyPr>
           <a:lstStyle/>
@@ -5715,7 +5726,7 @@
           <a:noFill/>
         </p:spPr>
         <p:txBody>
-          <a:bodyPr wrap="square" anchor="t" lIns="0" tIns="0" rIns="0" bIns="0">
+          <a:bodyPr wrap="square" lIns="0" tIns="0" rIns="0" bIns="0" anchor="t">
             <a:spAutoFit/>
           </a:bodyPr>
           <a:lstStyle/>
@@ -5785,7 +5796,7 @@
           <a:noFill/>
         </p:spPr>
         <p:txBody>
-          <a:bodyPr wrap="square" anchor="t" lIns="0" tIns="0" rIns="0" bIns="0">
+          <a:bodyPr wrap="square" lIns="0" tIns="0" rIns="0" bIns="0" anchor="t">
             <a:spAutoFit/>
           </a:bodyPr>
           <a:lstStyle/>
@@ -5812,7 +5823,7 @@
 </file>
 
 <file path=ppt/slides/slide4.xml><?xml version="1.0" encoding="utf-8"?>
-<p:sld xmlns:a="http://schemas.openxmlformats.org/drawingml/2006/main" xmlns:p="http://schemas.openxmlformats.org/presentationml/2006/main" xmlns:r="http://schemas.openxmlformats.org/officeDocument/2006/relationships">
+<p:sld xmlns:a="http://schemas.openxmlformats.org/drawingml/2006/main" xmlns:r="http://schemas.openxmlformats.org/officeDocument/2006/relationships" xmlns:p="http://schemas.openxmlformats.org/presentationml/2006/main">
   <p:cSld>
     <p:bg>
       <p:bgPr>
@@ -5828,7 +5839,14 @@
         <p:cNvGrpSpPr/>
         <p:nvPr/>
       </p:nvGrpSpPr>
-      <p:grpSpPr/>
+      <p:grpSpPr>
+        <a:xfrm>
+          <a:off x="0" y="0"/>
+          <a:ext cx="0" cy="0"/>
+          <a:chOff x="0" y="0"/>
+          <a:chExt cx="0" cy="0"/>
+        </a:xfrm>
+      </p:grpSpPr>
       <p:sp>
         <p:nvSpPr>
           <p:cNvPr id="2" name="TextBox 1"/>
@@ -5846,7 +5864,7 @@
           <a:noFill/>
         </p:spPr>
         <p:txBody>
-          <a:bodyPr wrap="square" anchor="t" lIns="0" tIns="0" rIns="0" bIns="0">
+          <a:bodyPr wrap="square" lIns="0" tIns="0" rIns="0" bIns="0" anchor="t">
             <a:spAutoFit/>
           </a:bodyPr>
           <a:lstStyle/>
@@ -5881,7 +5899,7 @@
           <a:noFill/>
         </p:spPr>
         <p:txBody>
-          <a:bodyPr wrap="square" anchor="t" lIns="0" tIns="0" rIns="0" bIns="0">
+          <a:bodyPr wrap="square" lIns="0" tIns="0" rIns="0" bIns="0" anchor="t">
             <a:spAutoFit/>
           </a:bodyPr>
           <a:lstStyle/>
@@ -5951,7 +5969,7 @@
           <a:noFill/>
         </p:spPr>
         <p:txBody>
-          <a:bodyPr wrap="square" anchor="t" lIns="0" tIns="0" rIns="0" bIns="0">
+          <a:bodyPr wrap="square" lIns="0" tIns="0" rIns="0" bIns="0" anchor="t">
             <a:spAutoFit/>
           </a:bodyPr>
           <a:lstStyle/>
@@ -6024,17 +6042,6 @@
           </a:p>
           <a:p>
             <a:br/>
-            <a:pPr>
-              <a:spcAft>
-                <a:spcPts val="800"/>
-              </a:spcAft>
-              <a:defRPr sz="1500" b="1">
-                <a:solidFill>
-                  <a:srgbClr val="134E4A"/>
-                </a:solidFill>
-                <a:latin typeface="Malgun Gothic"/>
-              </a:defRPr>
-            </a:pPr>
             <a:r>
               <a:t>• 파인다이닝의 예약 부도(No-Show) 차단</a:t>
             </a:r>
@@ -6057,17 +6064,6 @@
           </a:p>
           <a:p>
             <a:br/>
-            <a:pPr>
-              <a:spcAft>
-                <a:spcPts val="800"/>
-              </a:spcAft>
-              <a:defRPr sz="1500" b="1">
-                <a:solidFill>
-                  <a:srgbClr val="134E4A"/>
-                </a:solidFill>
-                <a:latin typeface="Malgun Gothic"/>
-              </a:defRPr>
-            </a:pPr>
             <a:r>
               <a:t>• 테이블 불확실성 해소</a:t>
             </a:r>
@@ -6099,7 +6095,7 @@
 </file>
 
 <file path=ppt/slides/slide5.xml><?xml version="1.0" encoding="utf-8"?>
-<p:sld xmlns:a="http://schemas.openxmlformats.org/drawingml/2006/main" xmlns:p="http://schemas.openxmlformats.org/presentationml/2006/main" xmlns:r="http://schemas.openxmlformats.org/officeDocument/2006/relationships">
+<p:sld xmlns:a="http://schemas.openxmlformats.org/drawingml/2006/main" xmlns:r="http://schemas.openxmlformats.org/officeDocument/2006/relationships" xmlns:p="http://schemas.openxmlformats.org/presentationml/2006/main">
   <p:cSld>
     <p:bg>
       <p:bgPr>
@@ -6115,7 +6111,14 @@
         <p:cNvGrpSpPr/>
         <p:nvPr/>
       </p:nvGrpSpPr>
-      <p:grpSpPr/>
+      <p:grpSpPr>
+        <a:xfrm>
+          <a:off x="0" y="0"/>
+          <a:ext cx="0" cy="0"/>
+          <a:chOff x="0" y="0"/>
+          <a:chExt cx="0" cy="0"/>
+        </a:xfrm>
+      </p:grpSpPr>
       <p:sp>
         <p:nvSpPr>
           <p:cNvPr id="2" name="TextBox 1"/>
@@ -6133,7 +6136,7 @@
           <a:noFill/>
         </p:spPr>
         <p:txBody>
-          <a:bodyPr wrap="square" anchor="t" lIns="0" tIns="0" rIns="0" bIns="0">
+          <a:bodyPr wrap="square" lIns="0" tIns="0" rIns="0" bIns="0" anchor="t">
             <a:spAutoFit/>
           </a:bodyPr>
           <a:lstStyle/>
@@ -6168,7 +6171,7 @@
           <a:noFill/>
         </p:spPr>
         <p:txBody>
-          <a:bodyPr wrap="square" anchor="t" lIns="0" tIns="0" rIns="0" bIns="0">
+          <a:bodyPr wrap="square" lIns="0" tIns="0" rIns="0" bIns="0" anchor="t">
             <a:spAutoFit/>
           </a:bodyPr>
           <a:lstStyle/>
@@ -6238,7 +6241,7 @@
           <a:noFill/>
         </p:spPr>
         <p:txBody>
-          <a:bodyPr wrap="square" anchor="t" lIns="0" tIns="0" rIns="0" bIns="0">
+          <a:bodyPr wrap="square" lIns="0" tIns="0" rIns="0" bIns="0" anchor="t">
             <a:spAutoFit/>
           </a:bodyPr>
           <a:lstStyle/>
@@ -6290,8 +6293,38 @@
               </a:defRPr>
             </a:pPr>
             <a:r>
-              <a:t>• 원스톱 미식 예약 여정</a:t>
-            </a:r>
+              <a:rPr dirty="0"/>
+              <a:t>• </a:t>
+            </a:r>
+            <a:r>
+              <a:rPr dirty="0" err="1"/>
+              <a:t>원스톱</a:t>
+            </a:r>
+            <a:r>
+              <a:rPr dirty="0"/>
+              <a:t> </a:t>
+            </a:r>
+            <a:r>
+              <a:rPr dirty="0" err="1"/>
+              <a:t>미식</a:t>
+            </a:r>
+            <a:r>
+              <a:rPr dirty="0"/>
+              <a:t> </a:t>
+            </a:r>
+            <a:r>
+              <a:rPr dirty="0" err="1"/>
+              <a:t>예약</a:t>
+            </a:r>
+            <a:r>
+              <a:rPr dirty="0"/>
+              <a:t> </a:t>
+            </a:r>
+            <a:r>
+              <a:rPr dirty="0" err="1"/>
+              <a:t>여정</a:t>
+            </a:r>
+            <a:endParaRPr dirty="0"/>
           </a:p>
           <a:p>
             <a:pPr>
@@ -6306,24 +6339,161 @@
               </a:defRPr>
             </a:pPr>
             <a:r>
-              <a:t>  - 날짜/시간 지정 ➡️ 2D 좌석 지도 지정 ➡️ 코스 요리 메뉴 선택(장바구니) 및 모의 결제 연동.</a:t>
-            </a:r>
-          </a:p>
-          <a:p>
-            <a:br/>
-            <a:pPr>
-              <a:spcAft>
-                <a:spcPts val="800"/>
-              </a:spcAft>
-              <a:defRPr sz="1500" b="1">
-                <a:solidFill>
-                  <a:srgbClr val="134E4A"/>
-                </a:solidFill>
-                <a:latin typeface="Malgun Gothic"/>
-              </a:defRPr>
-            </a:pPr>
-            <a:r>
-              <a:t>• 시각적 2D 좌석 배치도 (SeatMap)</a:t>
+              <a:rPr dirty="0"/>
+              <a:t>  - </a:t>
+            </a:r>
+            <a:r>
+              <a:rPr dirty="0" err="1"/>
+              <a:t>날짜</a:t>
+            </a:r>
+            <a:r>
+              <a:rPr dirty="0"/>
+              <a:t>/</a:t>
+            </a:r>
+            <a:r>
+              <a:rPr dirty="0" err="1"/>
+              <a:t>시간</a:t>
+            </a:r>
+            <a:r>
+              <a:rPr dirty="0"/>
+              <a:t> </a:t>
+            </a:r>
+            <a:r>
+              <a:rPr dirty="0" err="1"/>
+              <a:t>지정</a:t>
+            </a:r>
+            <a:r>
+              <a:rPr dirty="0"/>
+              <a:t> ➡️ 2D </a:t>
+            </a:r>
+            <a:r>
+              <a:rPr dirty="0" err="1"/>
+              <a:t>좌석</a:t>
+            </a:r>
+            <a:r>
+              <a:rPr dirty="0"/>
+              <a:t> </a:t>
+            </a:r>
+            <a:r>
+              <a:rPr dirty="0" err="1"/>
+              <a:t>지도</a:t>
+            </a:r>
+            <a:r>
+              <a:rPr dirty="0"/>
+              <a:t> </a:t>
+            </a:r>
+            <a:r>
+              <a:rPr dirty="0" err="1"/>
+              <a:t>지정</a:t>
+            </a:r>
+            <a:r>
+              <a:rPr dirty="0"/>
+              <a:t> ➡️ </a:t>
+            </a:r>
+            <a:r>
+              <a:rPr dirty="0" err="1"/>
+              <a:t>코스</a:t>
+            </a:r>
+            <a:r>
+              <a:rPr dirty="0"/>
+              <a:t> </a:t>
+            </a:r>
+            <a:r>
+              <a:rPr dirty="0" err="1"/>
+              <a:t>요리</a:t>
+            </a:r>
+            <a:r>
+              <a:rPr dirty="0"/>
+              <a:t> </a:t>
+            </a:r>
+            <a:r>
+              <a:rPr dirty="0" err="1"/>
+              <a:t>메뉴</a:t>
+            </a:r>
+            <a:r>
+              <a:rPr dirty="0"/>
+              <a:t> </a:t>
+            </a:r>
+            <a:r>
+              <a:rPr dirty="0" err="1"/>
+              <a:t>선택</a:t>
+            </a:r>
+            <a:r>
+              <a:rPr dirty="0"/>
+              <a:t>(</a:t>
+            </a:r>
+            <a:r>
+              <a:rPr dirty="0" err="1"/>
+              <a:t>장바구니</a:t>
+            </a:r>
+            <a:r>
+              <a:rPr dirty="0"/>
+              <a:t>) 및 </a:t>
+            </a:r>
+            <a:r>
+              <a:rPr dirty="0" err="1"/>
+              <a:t>모의</a:t>
+            </a:r>
+            <a:r>
+              <a:rPr dirty="0"/>
+              <a:t> </a:t>
+            </a:r>
+            <a:r>
+              <a:rPr dirty="0" err="1"/>
+              <a:t>결제</a:t>
+            </a:r>
+            <a:r>
+              <a:rPr dirty="0"/>
+              <a:t> </a:t>
+            </a:r>
+            <a:r>
+              <a:rPr dirty="0" err="1"/>
+              <a:t>연동</a:t>
+            </a:r>
+            <a:r>
+              <a:rPr dirty="0"/>
+              <a:t>.</a:t>
+            </a:r>
+          </a:p>
+          <a:p>
+            <a:br>
+              <a:rPr dirty="0"/>
+            </a:br>
+            <a:r>
+              <a:rPr dirty="0"/>
+              <a:t>• </a:t>
+            </a:r>
+            <a:r>
+              <a:rPr dirty="0" err="1"/>
+              <a:t>시각적</a:t>
+            </a:r>
+            <a:r>
+              <a:rPr dirty="0"/>
+              <a:t> 2D </a:t>
+            </a:r>
+            <a:r>
+              <a:rPr dirty="0" err="1"/>
+              <a:t>좌석</a:t>
+            </a:r>
+            <a:r>
+              <a:rPr dirty="0"/>
+              <a:t> </a:t>
+            </a:r>
+            <a:r>
+              <a:rPr dirty="0" err="1"/>
+              <a:t>배치도</a:t>
+            </a:r>
+            <a:r>
+              <a:rPr dirty="0"/>
+              <a:t> (</a:t>
+            </a:r>
+            <a:r>
+              <a:rPr dirty="0" err="1"/>
+              <a:t>SeatMap</a:t>
+            </a:r>
+            <a:r>
+              <a:rPr dirty="0"/>
+              <a:t>)</a:t>
             </a:r>
           </a:p>
           <a:p>
@@ -6339,25 +6509,135 @@
               </a:defRPr>
             </a:pPr>
             <a:r>
-              <a:t>  - 매장의 창가석, 프라이빗 룸, 테라스 등 공간 배치를 입체적으로 확인하고 선점 가능한 환경 제공.</a:t>
-            </a:r>
-          </a:p>
-          <a:p>
-            <a:br/>
-            <a:pPr>
-              <a:spcAft>
-                <a:spcPts val="800"/>
-              </a:spcAft>
-              <a:defRPr sz="1500" b="1">
-                <a:solidFill>
-                  <a:srgbClr val="134E4A"/>
-                </a:solidFill>
-                <a:latin typeface="Malgun Gothic"/>
-              </a:defRPr>
-            </a:pPr>
-            <a:r>
-              <a:t>• AI 컨시어지 상담 연계</a:t>
-            </a:r>
+              <a:rPr dirty="0"/>
+              <a:t>  - </a:t>
+            </a:r>
+            <a:r>
+              <a:rPr dirty="0" err="1"/>
+              <a:t>매장의</a:t>
+            </a:r>
+            <a:r>
+              <a:rPr dirty="0"/>
+              <a:t> </a:t>
+            </a:r>
+            <a:r>
+              <a:rPr dirty="0" err="1"/>
+              <a:t>창가석</a:t>
+            </a:r>
+            <a:r>
+              <a:rPr dirty="0"/>
+              <a:t>, </a:t>
+            </a:r>
+            <a:r>
+              <a:rPr dirty="0" err="1"/>
+              <a:t>프라이빗</a:t>
+            </a:r>
+            <a:r>
+              <a:rPr dirty="0"/>
+              <a:t> 룸, </a:t>
+            </a:r>
+            <a:r>
+              <a:rPr dirty="0" err="1"/>
+              <a:t>테라스</a:t>
+            </a:r>
+            <a:r>
+              <a:rPr dirty="0"/>
+              <a:t> 등 </a:t>
+            </a:r>
+            <a:r>
+              <a:rPr dirty="0" err="1"/>
+              <a:t>공간</a:t>
+            </a:r>
+            <a:r>
+              <a:rPr dirty="0"/>
+              <a:t> </a:t>
+            </a:r>
+            <a:r>
+              <a:rPr dirty="0" err="1"/>
+              <a:t>배치를</a:t>
+            </a:r>
+            <a:r>
+              <a:rPr dirty="0"/>
+              <a:t> </a:t>
+            </a:r>
+            <a:r>
+              <a:rPr dirty="0" err="1"/>
+              <a:t>입체적으로</a:t>
+            </a:r>
+            <a:r>
+              <a:rPr dirty="0"/>
+              <a:t> </a:t>
+            </a:r>
+            <a:r>
+              <a:rPr dirty="0" err="1"/>
+              <a:t>확인하고</a:t>
+            </a:r>
+            <a:r>
+              <a:rPr dirty="0"/>
+              <a:t> </a:t>
+            </a:r>
+            <a:r>
+              <a:rPr dirty="0" err="1"/>
+              <a:t>선점</a:t>
+            </a:r>
+            <a:r>
+              <a:rPr dirty="0"/>
+              <a:t> </a:t>
+            </a:r>
+            <a:r>
+              <a:rPr dirty="0" err="1"/>
+              <a:t>가능한</a:t>
+            </a:r>
+            <a:r>
+              <a:rPr dirty="0"/>
+              <a:t> </a:t>
+            </a:r>
+            <a:r>
+              <a:rPr dirty="0" err="1"/>
+              <a:t>환경</a:t>
+            </a:r>
+            <a:r>
+              <a:rPr dirty="0"/>
+              <a:t> </a:t>
+            </a:r>
+            <a:r>
+              <a:rPr dirty="0" err="1"/>
+              <a:t>제공</a:t>
+            </a:r>
+            <a:r>
+              <a:rPr dirty="0"/>
+              <a:t>.</a:t>
+            </a:r>
+          </a:p>
+          <a:p>
+            <a:br>
+              <a:rPr dirty="0"/>
+            </a:br>
+            <a:r>
+              <a:rPr dirty="0"/>
+              <a:t>• AI </a:t>
+            </a:r>
+            <a:r>
+              <a:rPr dirty="0" err="1"/>
+              <a:t>컨시어지</a:t>
+            </a:r>
+            <a:r>
+              <a:rPr dirty="0"/>
+              <a:t> </a:t>
+            </a:r>
+            <a:r>
+              <a:rPr dirty="0" err="1"/>
+              <a:t>상담</a:t>
+            </a:r>
+            <a:r>
+              <a:rPr dirty="0"/>
+              <a:t> </a:t>
+            </a:r>
+            <a:r>
+              <a:rPr dirty="0" err="1"/>
+              <a:t>연계</a:t>
+            </a:r>
+            <a:endParaRPr dirty="0"/>
           </a:p>
           <a:p>
             <a:pPr>
@@ -6372,7 +6652,80 @@
               </a:defRPr>
             </a:pPr>
             <a:r>
-              <a:t>  - 매장 지식 데이터베이스와 유기적으로 소통하여 24시간 정확한 소비자 안내 제공.</a:t>
+              <a:rPr dirty="0"/>
+              <a:t>  - </a:t>
+            </a:r>
+            <a:r>
+              <a:rPr dirty="0" err="1"/>
+              <a:t>매장</a:t>
+            </a:r>
+            <a:r>
+              <a:rPr dirty="0"/>
+              <a:t> </a:t>
+            </a:r>
+            <a:r>
+              <a:rPr dirty="0" err="1"/>
+              <a:t>지식</a:t>
+            </a:r>
+            <a:r>
+              <a:rPr dirty="0"/>
+              <a:t> </a:t>
+            </a:r>
+            <a:r>
+              <a:rPr dirty="0" err="1"/>
+              <a:t>데이터베이스와</a:t>
+            </a:r>
+            <a:r>
+              <a:rPr dirty="0"/>
+              <a:t> </a:t>
+            </a:r>
+            <a:r>
+              <a:rPr dirty="0" err="1"/>
+              <a:t>유기적으로</a:t>
+            </a:r>
+            <a:r>
+              <a:rPr dirty="0"/>
+              <a:t> </a:t>
+            </a:r>
+            <a:r>
+              <a:rPr dirty="0" err="1"/>
+              <a:t>소통하여</a:t>
+            </a:r>
+            <a:r>
+              <a:rPr dirty="0"/>
+              <a:t> 24시간 </a:t>
+            </a:r>
+            <a:r>
+              <a:rPr dirty="0" err="1"/>
+              <a:t>정확한</a:t>
+            </a:r>
+            <a:r>
+              <a:rPr dirty="0"/>
+              <a:t> </a:t>
+            </a:r>
+            <a:r>
+              <a:rPr dirty="0" err="1"/>
+              <a:t>소비자</a:t>
+            </a:r>
+            <a:r>
+              <a:rPr dirty="0"/>
+              <a:t> </a:t>
+            </a:r>
+            <a:r>
+              <a:rPr dirty="0" err="1"/>
+              <a:t>안내</a:t>
+            </a:r>
+            <a:r>
+              <a:rPr dirty="0"/>
+              <a:t> </a:t>
+            </a:r>
+            <a:r>
+              <a:rPr dirty="0" err="1"/>
+              <a:t>제공</a:t>
+            </a:r>
+            <a:r>
+              <a:rPr dirty="0"/>
+              <a:t>.</a:t>
             </a:r>
           </a:p>
         </p:txBody>
@@ -6386,7 +6739,7 @@
 </file>
 
 <file path=ppt/slides/slide6.xml><?xml version="1.0" encoding="utf-8"?>
-<p:sld xmlns:a="http://schemas.openxmlformats.org/drawingml/2006/main" xmlns:p="http://schemas.openxmlformats.org/presentationml/2006/main" xmlns:r="http://schemas.openxmlformats.org/officeDocument/2006/relationships">
+<p:sld xmlns:a="http://schemas.openxmlformats.org/drawingml/2006/main" xmlns:r="http://schemas.openxmlformats.org/officeDocument/2006/relationships" xmlns:p="http://schemas.openxmlformats.org/presentationml/2006/main">
   <p:cSld>
     <p:bg>
       <p:bgPr>
@@ -6402,7 +6755,14 @@
         <p:cNvGrpSpPr/>
         <p:nvPr/>
       </p:nvGrpSpPr>
-      <p:grpSpPr/>
+      <p:grpSpPr>
+        <a:xfrm>
+          <a:off x="0" y="0"/>
+          <a:ext cx="0" cy="0"/>
+          <a:chOff x="0" y="0"/>
+          <a:chExt cx="0" cy="0"/>
+        </a:xfrm>
+      </p:grpSpPr>
       <p:sp>
         <p:nvSpPr>
           <p:cNvPr id="2" name="TextBox 1"/>
@@ -6420,7 +6780,7 @@
           <a:noFill/>
         </p:spPr>
         <p:txBody>
-          <a:bodyPr wrap="square" anchor="t" lIns="0" tIns="0" rIns="0" bIns="0">
+          <a:bodyPr wrap="square" lIns="0" tIns="0" rIns="0" bIns="0" anchor="t">
             <a:spAutoFit/>
           </a:bodyPr>
           <a:lstStyle/>
@@ -6455,7 +6815,7 @@
           <a:noFill/>
         </p:spPr>
         <p:txBody>
-          <a:bodyPr wrap="square" anchor="t" lIns="0" tIns="0" rIns="0" bIns="0">
+          <a:bodyPr wrap="square" lIns="0" tIns="0" rIns="0" bIns="0" anchor="t">
             <a:spAutoFit/>
           </a:bodyPr>
           <a:lstStyle/>
@@ -6525,7 +6885,7 @@
           <a:noFill/>
         </p:spPr>
         <p:txBody>
-          <a:bodyPr wrap="square" anchor="t" lIns="0" tIns="0" rIns="0" bIns="0">
+          <a:bodyPr wrap="square" lIns="0" tIns="0" rIns="0" bIns="0" anchor="t">
             <a:spAutoFit/>
           </a:bodyPr>
           <a:lstStyle/>
@@ -6552,7 +6912,7 @@
 </file>
 
 <file path=ppt/slides/slide7.xml><?xml version="1.0" encoding="utf-8"?>
-<p:sld xmlns:a="http://schemas.openxmlformats.org/drawingml/2006/main" xmlns:p="http://schemas.openxmlformats.org/presentationml/2006/main" xmlns:r="http://schemas.openxmlformats.org/officeDocument/2006/relationships">
+<p:sld xmlns:a="http://schemas.openxmlformats.org/drawingml/2006/main" xmlns:r="http://schemas.openxmlformats.org/officeDocument/2006/relationships" xmlns:p="http://schemas.openxmlformats.org/presentationml/2006/main">
   <p:cSld>
     <p:bg>
       <p:bgPr>
@@ -6568,7 +6928,14 @@
         <p:cNvGrpSpPr/>
         <p:nvPr/>
       </p:nvGrpSpPr>
-      <p:grpSpPr/>
+      <p:grpSpPr>
+        <a:xfrm>
+          <a:off x="0" y="0"/>
+          <a:ext cx="0" cy="0"/>
+          <a:chOff x="0" y="0"/>
+          <a:chExt cx="0" cy="0"/>
+        </a:xfrm>
+      </p:grpSpPr>
       <p:sp>
         <p:nvSpPr>
           <p:cNvPr id="2" name="TextBox 1"/>
@@ -6586,7 +6953,7 @@
           <a:noFill/>
         </p:spPr>
         <p:txBody>
-          <a:bodyPr wrap="square" anchor="t" lIns="0" tIns="0" rIns="0" bIns="0">
+          <a:bodyPr wrap="square" lIns="0" tIns="0" rIns="0" bIns="0" anchor="t">
             <a:spAutoFit/>
           </a:bodyPr>
           <a:lstStyle/>
@@ -6621,7 +6988,7 @@
           <a:noFill/>
         </p:spPr>
         <p:txBody>
-          <a:bodyPr wrap="square" anchor="t" lIns="0" tIns="0" rIns="0" bIns="0">
+          <a:bodyPr wrap="square" lIns="0" tIns="0" rIns="0" bIns="0" anchor="t">
             <a:spAutoFit/>
           </a:bodyPr>
           <a:lstStyle/>
@@ -6691,7 +7058,7 @@
           <a:noFill/>
         </p:spPr>
         <p:txBody>
-          <a:bodyPr wrap="square" anchor="t" lIns="0" tIns="0" rIns="0" bIns="0">
+          <a:bodyPr wrap="square" lIns="0" tIns="0" rIns="0" bIns="0" anchor="t">
             <a:spAutoFit/>
           </a:bodyPr>
           <a:lstStyle/>
@@ -6780,17 +7147,6 @@
           </a:p>
           <a:p>
             <a:br/>
-            <a:pPr>
-              <a:spcAft>
-                <a:spcPts val="800"/>
-              </a:spcAft>
-              <a:defRPr sz="1400" b="1">
-                <a:solidFill>
-                  <a:srgbClr val="134E4A"/>
-                </a:solidFill>
-                <a:latin typeface="Malgun Gothic"/>
-              </a:defRPr>
-            </a:pPr>
             <a:r>
               <a:t>• 백엔드 서버 (Backend API &amp; Admin)</a:t>
             </a:r>
@@ -6845,17 +7201,6 @@
           </a:p>
           <a:p>
             <a:br/>
-            <a:pPr>
-              <a:spcAft>
-                <a:spcPts val="800"/>
-              </a:spcAft>
-              <a:defRPr sz="1400" b="1">
-                <a:solidFill>
-                  <a:srgbClr val="134E4A"/>
-                </a:solidFill>
-                <a:latin typeface="Malgun Gothic"/>
-              </a:defRPr>
-            </a:pPr>
             <a:r>
               <a:t>• 인공지능 (AI Scope)</a:t>
             </a:r>
@@ -6887,7 +7232,7 @@
 </file>
 
 <file path=ppt/slides/slide8.xml><?xml version="1.0" encoding="utf-8"?>
-<p:sld xmlns:a="http://schemas.openxmlformats.org/drawingml/2006/main" xmlns:p="http://schemas.openxmlformats.org/presentationml/2006/main" xmlns:r="http://schemas.openxmlformats.org/officeDocument/2006/relationships">
+<p:sld xmlns:a="http://schemas.openxmlformats.org/drawingml/2006/main" xmlns:r="http://schemas.openxmlformats.org/officeDocument/2006/relationships" xmlns:p="http://schemas.openxmlformats.org/presentationml/2006/main">
   <p:cSld>
     <p:bg>
       <p:bgPr>
@@ -6903,7 +7248,14 @@
         <p:cNvGrpSpPr/>
         <p:nvPr/>
       </p:nvGrpSpPr>
-      <p:grpSpPr/>
+      <p:grpSpPr>
+        <a:xfrm>
+          <a:off x="0" y="0"/>
+          <a:ext cx="0" cy="0"/>
+          <a:chOff x="0" y="0"/>
+          <a:chExt cx="0" cy="0"/>
+        </a:xfrm>
+      </p:grpSpPr>
       <p:sp>
         <p:nvSpPr>
           <p:cNvPr id="2" name="TextBox 1"/>
@@ -6921,7 +7273,7 @@
           <a:noFill/>
         </p:spPr>
         <p:txBody>
-          <a:bodyPr wrap="square" anchor="t" lIns="0" tIns="0" rIns="0" bIns="0">
+          <a:bodyPr wrap="square" lIns="0" tIns="0" rIns="0" bIns="0" anchor="t">
             <a:spAutoFit/>
           </a:bodyPr>
           <a:lstStyle/>
@@ -6956,7 +7308,7 @@
           <a:noFill/>
         </p:spPr>
         <p:txBody>
-          <a:bodyPr wrap="square" anchor="t" lIns="0" tIns="0" rIns="0" bIns="0">
+          <a:bodyPr wrap="square" lIns="0" tIns="0" rIns="0" bIns="0" anchor="t">
             <a:spAutoFit/>
           </a:bodyPr>
           <a:lstStyle/>
@@ -7026,7 +7378,7 @@
           <a:noFill/>
         </p:spPr>
         <p:txBody>
-          <a:bodyPr wrap="square" anchor="t" lIns="0" tIns="0" rIns="0" bIns="0">
+          <a:bodyPr wrap="square" lIns="0" tIns="0" rIns="0" bIns="0" anchor="t">
             <a:spAutoFit/>
           </a:bodyPr>
           <a:lstStyle/>
@@ -7053,7 +7405,7 @@
 </file>
 
 <file path=ppt/slides/slide9.xml><?xml version="1.0" encoding="utf-8"?>
-<p:sld xmlns:a="http://schemas.openxmlformats.org/drawingml/2006/main" xmlns:p="http://schemas.openxmlformats.org/presentationml/2006/main" xmlns:r="http://schemas.openxmlformats.org/officeDocument/2006/relationships">
+<p:sld xmlns:a="http://schemas.openxmlformats.org/drawingml/2006/main" xmlns:r="http://schemas.openxmlformats.org/officeDocument/2006/relationships" xmlns:p="http://schemas.openxmlformats.org/presentationml/2006/main">
   <p:cSld>
     <p:bg>
       <p:bgPr>
@@ -7069,7 +7421,14 @@
         <p:cNvGrpSpPr/>
         <p:nvPr/>
       </p:nvGrpSpPr>
-      <p:grpSpPr/>
+      <p:grpSpPr>
+        <a:xfrm>
+          <a:off x="0" y="0"/>
+          <a:ext cx="0" cy="0"/>
+          <a:chOff x="0" y="0"/>
+          <a:chExt cx="0" cy="0"/>
+        </a:xfrm>
+      </p:grpSpPr>
       <p:sp>
         <p:nvSpPr>
           <p:cNvPr id="2" name="TextBox 1"/>
@@ -7087,7 +7446,7 @@
           <a:noFill/>
         </p:spPr>
         <p:txBody>
-          <a:bodyPr wrap="square" anchor="t" lIns="0" tIns="0" rIns="0" bIns="0">
+          <a:bodyPr wrap="square" lIns="0" tIns="0" rIns="0" bIns="0" anchor="t">
             <a:spAutoFit/>
           </a:bodyPr>
           <a:lstStyle/>
@@ -7122,7 +7481,7 @@
           <a:noFill/>
         </p:spPr>
         <p:txBody>
-          <a:bodyPr wrap="square" anchor="t" lIns="0" tIns="0" rIns="0" bIns="0">
+          <a:bodyPr wrap="square" lIns="0" tIns="0" rIns="0" bIns="0" anchor="t">
             <a:spAutoFit/>
           </a:bodyPr>
           <a:lstStyle/>
@@ -7192,7 +7551,7 @@
           <a:noFill/>
         </p:spPr>
         <p:txBody>
-          <a:bodyPr wrap="square" anchor="t" lIns="0" tIns="0" rIns="0" bIns="0">
+          <a:bodyPr wrap="square" lIns="0" tIns="0" rIns="0" bIns="0" anchor="t">
             <a:spAutoFit/>
           </a:bodyPr>
           <a:lstStyle/>
@@ -7219,7 +7578,7 @@
         <p:spPr>
           <a:xfrm>
             <a:off x="731520" y="1828800"/>
-            <a:ext cx="6858000" cy="4114800"/>
+            <a:ext cx="6858000" cy="2041585"/>
           </a:xfrm>
           <a:prstGeom prst="rect">
             <a:avLst/>
@@ -7244,8 +7603,38 @@
               </a:defRPr>
             </a:pPr>
             <a:r>
-              <a:t>• 토스(TOSS) UI 디자인 스타일 계승</a:t>
-            </a:r>
+              <a:rPr dirty="0"/>
+              <a:t>• </a:t>
+            </a:r>
+            <a:r>
+              <a:rPr dirty="0" err="1"/>
+              <a:t>토스</a:t>
+            </a:r>
+            <a:r>
+              <a:rPr dirty="0"/>
+              <a:t>(TOSS) UI </a:t>
+            </a:r>
+            <a:r>
+              <a:rPr dirty="0" err="1"/>
+              <a:t>디자인</a:t>
+            </a:r>
+            <a:r>
+              <a:rPr dirty="0"/>
+              <a:t> </a:t>
+            </a:r>
+            <a:r>
+              <a:rPr dirty="0" err="1"/>
+              <a:t>스타일</a:t>
+            </a:r>
+            <a:r>
+              <a:rPr dirty="0"/>
+              <a:t> </a:t>
+            </a:r>
+            <a:r>
+              <a:rPr dirty="0" err="1"/>
+              <a:t>계승</a:t>
+            </a:r>
+            <a:endParaRPr dirty="0"/>
           </a:p>
           <a:p>
             <a:pPr>
@@ -7260,7 +7649,80 @@
               </a:defRPr>
             </a:pPr>
             <a:r>
-              <a:t>  - 군더더기 없는 플랫 둥근 카드 레이아웃과 명료한 Toss Blue 테마 적용.</a:t>
+              <a:rPr dirty="0"/>
+              <a:t>  - </a:t>
+            </a:r>
+            <a:r>
+              <a:rPr dirty="0" err="1"/>
+              <a:t>군더더기</a:t>
+            </a:r>
+            <a:r>
+              <a:rPr dirty="0"/>
+              <a:t> </a:t>
+            </a:r>
+            <a:r>
+              <a:rPr dirty="0" err="1"/>
+              <a:t>없는</a:t>
+            </a:r>
+            <a:r>
+              <a:rPr dirty="0"/>
+              <a:t> </a:t>
+            </a:r>
+            <a:r>
+              <a:rPr dirty="0" err="1"/>
+              <a:t>플랫</a:t>
+            </a:r>
+            <a:r>
+              <a:rPr dirty="0"/>
+              <a:t> </a:t>
+            </a:r>
+            <a:r>
+              <a:rPr dirty="0" err="1"/>
+              <a:t>둥근</a:t>
+            </a:r>
+            <a:r>
+              <a:rPr dirty="0"/>
+              <a:t> </a:t>
+            </a:r>
+            <a:r>
+              <a:rPr dirty="0" err="1"/>
+              <a:t>카드</a:t>
+            </a:r>
+            <a:r>
+              <a:rPr dirty="0"/>
+              <a:t> </a:t>
+            </a:r>
+            <a:r>
+              <a:rPr dirty="0" err="1"/>
+              <a:t>레이아웃과</a:t>
+            </a:r>
+            <a:r>
+              <a:rPr dirty="0"/>
+              <a:t> </a:t>
+            </a:r>
+            <a:r>
+              <a:rPr dirty="0" err="1"/>
+              <a:t>명료한</a:t>
+            </a:r>
+            <a:r>
+              <a:rPr dirty="0"/>
+              <a:t> Toss Blue </a:t>
+            </a:r>
+            <a:r>
+              <a:rPr dirty="0" err="1"/>
+              <a:t>테마</a:t>
+            </a:r>
+            <a:r>
+              <a:rPr dirty="0"/>
+              <a:t> </a:t>
+            </a:r>
+            <a:r>
+              <a:rPr dirty="0" err="1"/>
+              <a:t>적용</a:t>
+            </a:r>
+            <a:r>
+              <a:rPr dirty="0"/>
+              <a:t>.</a:t>
             </a:r>
           </a:p>
           <a:p>
@@ -7276,25 +7738,119 @@
               </a:defRPr>
             </a:pPr>
             <a:r>
-              <a:t>  - 모바일 환경에서의 엄지 영역 접근성(하단 네비게이션 가이드) 극대화.</a:t>
-            </a:r>
-          </a:p>
-          <a:p>
-            <a:br/>
-            <a:pPr>
-              <a:spcAft>
-                <a:spcPts val="800"/>
-              </a:spcAft>
-              <a:defRPr sz="1400" b="1">
-                <a:solidFill>
-                  <a:srgbClr val="134E4A"/>
-                </a:solidFill>
-                <a:latin typeface="Malgun Gothic"/>
-              </a:defRPr>
-            </a:pPr>
-            <a:r>
-              <a:t>• 기민한(Agile) 점진적 작업 프로세스</a:t>
-            </a:r>
+              <a:rPr dirty="0"/>
+              <a:t>  - </a:t>
+            </a:r>
+            <a:r>
+              <a:rPr dirty="0" err="1"/>
+              <a:t>모바일</a:t>
+            </a:r>
+            <a:r>
+              <a:rPr dirty="0"/>
+              <a:t> </a:t>
+            </a:r>
+            <a:r>
+              <a:rPr dirty="0" err="1"/>
+              <a:t>환경에서의</a:t>
+            </a:r>
+            <a:r>
+              <a:rPr dirty="0"/>
+              <a:t> </a:t>
+            </a:r>
+            <a:r>
+              <a:rPr dirty="0" err="1"/>
+              <a:t>엄지</a:t>
+            </a:r>
+            <a:r>
+              <a:rPr dirty="0"/>
+              <a:t> </a:t>
+            </a:r>
+            <a:r>
+              <a:rPr dirty="0" err="1"/>
+              <a:t>영역</a:t>
+            </a:r>
+            <a:r>
+              <a:rPr dirty="0"/>
+              <a:t> </a:t>
+            </a:r>
+            <a:r>
+              <a:rPr dirty="0" err="1"/>
+              <a:t>접근성</a:t>
+            </a:r>
+            <a:r>
+              <a:rPr dirty="0"/>
+              <a:t>(</a:t>
+            </a:r>
+            <a:r>
+              <a:rPr dirty="0" err="1"/>
+              <a:t>하단</a:t>
+            </a:r>
+            <a:r>
+              <a:rPr dirty="0"/>
+              <a:t> </a:t>
+            </a:r>
+            <a:r>
+              <a:rPr dirty="0" err="1"/>
+              <a:t>네비게이션</a:t>
+            </a:r>
+            <a:r>
+              <a:rPr dirty="0"/>
+              <a:t> </a:t>
+            </a:r>
+            <a:r>
+              <a:rPr dirty="0" err="1"/>
+              <a:t>가이드</a:t>
+            </a:r>
+            <a:r>
+              <a:rPr dirty="0"/>
+              <a:t>) </a:t>
+            </a:r>
+            <a:r>
+              <a:rPr dirty="0" err="1"/>
+              <a:t>극대화</a:t>
+            </a:r>
+            <a:r>
+              <a:rPr dirty="0"/>
+              <a:t>.</a:t>
+            </a:r>
+          </a:p>
+          <a:p>
+            <a:br>
+              <a:rPr dirty="0"/>
+            </a:br>
+            <a:r>
+              <a:rPr dirty="0"/>
+              <a:t>• </a:t>
+            </a:r>
+            <a:r>
+              <a:rPr dirty="0" err="1"/>
+              <a:t>기민한</a:t>
+            </a:r>
+            <a:r>
+              <a:rPr dirty="0"/>
+              <a:t>(Agile) </a:t>
+            </a:r>
+            <a:r>
+              <a:rPr dirty="0" err="1"/>
+              <a:t>점진적</a:t>
+            </a:r>
+            <a:r>
+              <a:rPr dirty="0"/>
+              <a:t> </a:t>
+            </a:r>
+            <a:r>
+              <a:rPr dirty="0" err="1"/>
+              <a:t>작업</a:t>
+            </a:r>
+            <a:r>
+              <a:rPr dirty="0"/>
+              <a:t> </a:t>
+            </a:r>
+            <a:r>
+              <a:rPr dirty="0" err="1"/>
+              <a:t>프로세스</a:t>
+            </a:r>
+            <a:endParaRPr dirty="0"/>
           </a:p>
           <a:p>
             <a:pPr>
@@ -7309,7 +7865,80 @@
               </a:defRPr>
             </a:pPr>
             <a:r>
-              <a:t>  - DB 관계 모델링 ➡️ 핵심 예약 모듈 빌드 ➡️ AI 챗봇 연동 및 고도화.</a:t>
+              <a:rPr dirty="0"/>
+              <a:t>  - DB </a:t>
+            </a:r>
+            <a:r>
+              <a:rPr dirty="0" err="1"/>
+              <a:t>관계</a:t>
+            </a:r>
+            <a:r>
+              <a:rPr dirty="0"/>
+              <a:t> </a:t>
+            </a:r>
+            <a:r>
+              <a:rPr dirty="0" err="1"/>
+              <a:t>모델링</a:t>
+            </a:r>
+            <a:r>
+              <a:rPr dirty="0"/>
+              <a:t> ➡️ </a:t>
+            </a:r>
+            <a:r>
+              <a:rPr dirty="0" err="1"/>
+              <a:t>핵심</a:t>
+            </a:r>
+            <a:r>
+              <a:rPr dirty="0"/>
+              <a:t> </a:t>
+            </a:r>
+            <a:r>
+              <a:rPr dirty="0" err="1"/>
+              <a:t>예약</a:t>
+            </a:r>
+            <a:r>
+              <a:rPr dirty="0"/>
+              <a:t> </a:t>
+            </a:r>
+            <a:r>
+              <a:rPr dirty="0" err="1"/>
+              <a:t>모듈</a:t>
+            </a:r>
+            <a:r>
+              <a:rPr dirty="0"/>
+              <a:t> </a:t>
+            </a:r>
+            <a:r>
+              <a:rPr dirty="0" err="1"/>
+              <a:t>빌드</a:t>
+            </a:r>
+            <a:r>
+              <a:rPr dirty="0"/>
+              <a:t> ➡️ AI </a:t>
+            </a:r>
+            <a:r>
+              <a:rPr dirty="0" err="1"/>
+              <a:t>챗봇</a:t>
+            </a:r>
+            <a:r>
+              <a:rPr dirty="0"/>
+              <a:t> </a:t>
+            </a:r>
+            <a:r>
+              <a:rPr dirty="0" err="1"/>
+              <a:t>연동</a:t>
+            </a:r>
+            <a:r>
+              <a:rPr dirty="0"/>
+              <a:t> 및 </a:t>
+            </a:r>
+            <a:r>
+              <a:rPr dirty="0" err="1"/>
+              <a:t>고도화</a:t>
+            </a:r>
+            <a:r>
+              <a:rPr dirty="0"/>
+              <a:t>.</a:t>
             </a:r>
           </a:p>
           <a:p>
@@ -7325,7 +7954,8 @@
               </a:defRPr>
             </a:pPr>
             <a:r>
-              <a:t>  - 영화 예매 도메인 피드백 수렴 후 식당 예약 뼈대로 신속히 원상 복구 및 컨텍스트 동기화 수행.</a:t>
+              <a:rPr dirty="0"/>
+              <a:t>  </a:t>
             </a:r>
           </a:p>
         </p:txBody>
@@ -7346,8 +7976,8 @@
         </p:blipFill>
         <p:spPr>
           <a:xfrm>
-            <a:off x="8046720" y="1828800"/>
-            <a:ext cx="3474720" cy="7519804"/>
+            <a:off x="8768516" y="1734207"/>
+            <a:ext cx="2242121" cy="4852278"/>
           </a:xfrm>
           <a:prstGeom prst="rect">
             <a:avLst/>

</xml_diff>